<commit_message>
Kafka-Appell: Reflexionsfrage eindeutig formuliert (angenommen, der Vater hätte den Brief gelesen)
Co-Authored-By: Claude Opus 5.5 <noreply@anthropic.com>
Claude-Session: https://claude.ai/code/session_01Kzh1oWiqhC6W8oSNq8mKnj
</commit_message>
<xml_diff>
--- a/Deutsch_11/Kafka_Appell/Praesentation_Kafkas_Appell.pptx
+++ b/Deutsch_11/Kafka_Appell/Praesentation_Kafkas_Appell.pptx
@@ -3305,7 +3305,7 @@
         <p:spPr>
           <a:xfrm>
             <a:off x="822960" y="3291840"/>
-            <a:ext cx="10424160" cy="1463040"/>
+            <a:ext cx="10424160" cy="2377440"/>
           </a:xfrm>
           <a:prstGeom prst="rect">
             <a:avLst/>
@@ -3352,7 +3352,7 @@
                 <a:ea typeface="Calibri" pitchFamily="34" charset="-122"/>
                 <a:cs typeface="Calibri" pitchFamily="34" charset="-120"/>
               </a:rPr>
-              <a:t>Hätte der Vater die Bitte verstanden?</a:t>
+              <a:t>Angenommen, der Vater hätte den Brief gelesen: Hätte er verstanden, worum Kafka ihn bittet?</a:t>
             </a:r>
             <a:endParaRPr lang="en-US" sz="2700" dirty="0"/>
           </a:p>

</xml_diff>

<commit_message>
Kafka-Appell: Änderungen der Lehrkraft an der Präsentation übernommen und gestalterisch angeglichen, Ablauf angepasst
Co-Authored-By: Claude Opus 5.5 <noreply@anthropic.com>
Claude-Session: https://claude.ai/code/session_01Kzh1oWiqhC6W8oSNq8mKnj
</commit_message>
<xml_diff>
--- a/Deutsch_11/Kafka_Appell/Praesentation_Kafkas_Appell.pptx
+++ b/Deutsch_11/Kafka_Appell/Praesentation_Kafkas_Appell.pptx
@@ -19,9 +19,11 @@
     <p:sldId id="267" r:id="rId13"/>
     <p:sldId id="268" r:id="rId14"/>
     <p:sldId id="269" r:id="rId15"/>
+    <p:sldId id="270" r:id="rId16"/>
+    <p:sldId id="271" r:id="rId17"/>
   </p:sldIdLst>
   <p:notesMasterIdLst>
-    <p:notesMasterId r:id="rId16"/>
+    <p:notesMasterId r:id="rId18"/>
   </p:notesMasterIdLst>
   <p:sldSz cx="12192000" cy="6858000"/>
   <p:notesSz cx="6858000" cy="12192000"/>
@@ -603,7 +605,7 @@
           <a:p>
             <a:r>
               <a:rPr lang="en-US" dirty="0"/>
-              <a:t>Kontext-Box vom Arbeitsblatt vorlesen, dann den Auszug. Die Klasse liest auf dem Arbeitsblatt mit (Zeilennummern, Fußnoten).</a:t>
+              <a:t>Steht auch auf dem Arbeitsblatt (2. Information). Rückbezug: „Mein Appell vorhin war verdeckt – ich habe nur beschrieben, was schlecht war.“</a:t>
             </a:r>
             <a:endParaRPr lang="en-US" dirty="0"/>
           </a:p>
@@ -691,7 +693,7 @@
           <a:p>
             <a:r>
               <a:rPr lang="en-US" dirty="0"/>
-              <a:t>VERARBEITEN. Herumgehen. Wer bei Aufgabe 1 hängt: „Was soll der Vater nach diesem Satz anders machen?“</a:t>
+              <a:t>Kontext-Box vom Arbeitsblatt vorlesen, dann den Auszug. Die Klasse liest auf dem Arbeitsblatt mit (Zeilennummern, Fußnoten).</a:t>
             </a:r>
             <a:endParaRPr lang="en-US" dirty="0"/>
           </a:p>
@@ -779,7 +781,7 @@
           <a:p>
             <a:r>
               <a:rPr lang="en-US" dirty="0"/>
-              <a:t>Während der Besprechung stehen lassen: Antworten in ganzen Sätzen einfordern. Ergebnisse ins Quadrat an der Tafel (Appell groß). Achtung Komma: „…, dass der Vater …“ – Regel 2!</a:t>
+              <a:t>VERARBEITEN. Herumgehen. Wer hängt: „Was soll der Vater nach diesem Satz anders machen?“ Danach zwei Sätze vorlesen lassen, den treffendsten an die Tafel (②).</a:t>
             </a:r>
             <a:endParaRPr lang="en-US" dirty="0"/>
           </a:p>
@@ -867,7 +869,7 @@
           <a:p>
             <a:r>
               <a:rPr lang="en-US" dirty="0"/>
-              <a:t>Aufgabe 4 im Gespräch. Ziel: Furcht → verdeckter, abgesicherter Appell. Merksatz an die Tafel.</a:t>
+              <a:t>Leitfragen stehen auf dem Arbeitsblatt. Formulierungshilfen hier stehen lassen – auch für die Besprechung: Antworten in ganzen Sätzen einfordern. Kurz prüfen, bevor es mit Aufgabe 3 weitergeht.</a:t>
             </a:r>
             <a:endParaRPr lang="en-US" dirty="0"/>
           </a:p>
@@ -955,7 +957,7 @@
           <a:p>
             <a:r>
               <a:rPr lang="en-US" dirty="0"/>
-              <a:t>Aufgabe 5. Überleitung: „Max Brods Brief war erfolgreich – der Vater hört zu. Jetzt spricht Franz selbst, und zwar offen.“ Timer 10 Minuten, danach ein bis zwei Reden ohne Unterbrechung vortragen und nach den Kriterien auswerten. Wer nicht fertig ist, schreibt nächste Stunde weiter (keine Hausaufgabe). Hinweis: Substantive groß, Komma vor dass – auch bei „Ich hoffe, …“!</a:t>
+              <a:t>Danach Auswertung im Unterrichtsgespräch: Leitfragen der Reihe nach, Ergebnisse ins Quadrat an der Tafel (③), Appell zuletzt und groß.</a:t>
             </a:r>
             <a:endParaRPr lang="en-US" dirty="0"/>
           </a:p>
@@ -979,6 +981,182 @@
             <a:fld id="{F7021451-1387-4CA6-816F-3879F97B5CBC}" type="slidenum">
               <a:rPr lang="en-US"/>
               <a:t>14</a:t>
+            </a:fld>
+            <a:endParaRPr lang="en-US"/>
+          </a:p>
+        </p:txBody>
+      </p:sp>
+    </p:spTree>
+    <p:extLst>
+      <p:ext uri="{BB962C8B-B14F-4D97-AF65-F5344CB8AC3E}">
+        <p14:creationId xmlns:p14="http://schemas.microsoft.com/office/powerpoint/2010/main" val="1024086991"/>
+      </p:ext>
+    </p:extLst>
+  </p:cSld>
+  <p:clrMapOvr>
+    <a:masterClrMapping/>
+  </p:clrMapOvr>
+</p:notes>
+</file>
+
+<file path=ppt/notesSlides/notesSlide15.xml><?xml version="1.0" encoding="utf-8"?>
+<p:notes xmlns:a="http://schemas.openxmlformats.org/drawingml/2006/main" xmlns:r="http://schemas.openxmlformats.org/officeDocument/2006/relationships" xmlns:p="http://schemas.openxmlformats.org/presentationml/2006/main">
+  <p:cSld>
+    <p:spTree>
+      <p:nvGrpSpPr>
+        <p:cNvPr id="1" name=""/>
+        <p:cNvGrpSpPr/>
+        <p:nvPr/>
+      </p:nvGrpSpPr>
+      <p:grpSpPr>
+        <a:xfrm>
+          <a:off x="0" y="0"/>
+          <a:ext cx="0" cy="0"/>
+          <a:chOff x="0" y="0"/>
+          <a:chExt cx="0" cy="0"/>
+        </a:xfrm>
+      </p:grpSpPr>
+      <p:sp>
+        <p:nvSpPr>
+          <p:cNvPr id="2" name="Slide Image Placeholder 1"/>
+          <p:cNvSpPr>
+            <a:spLocks noGrp="1" noRot="1" noChangeAspect="1"/>
+          </p:cNvSpPr>
+          <p:nvPr>
+            <p:ph type="sldImg"/>
+          </p:nvPr>
+        </p:nvSpPr>
+        <p:spPr/>
+      </p:sp>
+      <p:sp>
+        <p:nvSpPr>
+          <p:cNvPr id="3" name="Notes Placeholder 2"/>
+          <p:cNvSpPr>
+            <a:spLocks noGrp="1"/>
+          </p:cNvSpPr>
+          <p:nvPr>
+            <p:ph type="body" idx="1"/>
+          </p:nvPr>
+        </p:nvSpPr>
+        <p:spPr/>
+        <p:txBody>
+          <a:bodyPr/>
+          <a:lstStyle/>
+          <a:p>
+            <a:r>
+              <a:rPr lang="en-US" dirty="0"/>
+              <a:t>Aufgabe 4 im Gespräch. Ziel: Furcht → verdeckter, abgesicherter Appell. Merksatz an die Tafel.</a:t>
+            </a:r>
+            <a:endParaRPr lang="en-US" dirty="0"/>
+          </a:p>
+        </p:txBody>
+      </p:sp>
+      <p:sp>
+        <p:nvSpPr>
+          <p:cNvPr id="4" name="Slide Number Placeholder 3"/>
+          <p:cNvSpPr>
+            <a:spLocks noGrp="1"/>
+          </p:cNvSpPr>
+          <p:nvPr>
+            <p:ph type="sldNum" sz="quarter" idx="10"/>
+          </p:nvPr>
+        </p:nvSpPr>
+        <p:spPr/>
+        <p:txBody>
+          <a:bodyPr/>
+          <a:lstStyle/>
+          <a:p>
+            <a:fld id="{F7021451-1387-4CA6-816F-3879F97B5CBC}" type="slidenum">
+              <a:rPr lang="en-US"/>
+              <a:t>15</a:t>
+            </a:fld>
+            <a:endParaRPr lang="en-US"/>
+          </a:p>
+        </p:txBody>
+      </p:sp>
+    </p:spTree>
+    <p:extLst>
+      <p:ext uri="{BB962C8B-B14F-4D97-AF65-F5344CB8AC3E}">
+        <p14:creationId xmlns:p14="http://schemas.microsoft.com/office/powerpoint/2010/main" val="1024086991"/>
+      </p:ext>
+    </p:extLst>
+  </p:cSld>
+  <p:clrMapOvr>
+    <a:masterClrMapping/>
+  </p:clrMapOvr>
+</p:notes>
+</file>
+
+<file path=ppt/notesSlides/notesSlide16.xml><?xml version="1.0" encoding="utf-8"?>
+<p:notes xmlns:a="http://schemas.openxmlformats.org/drawingml/2006/main" xmlns:r="http://schemas.openxmlformats.org/officeDocument/2006/relationships" xmlns:p="http://schemas.openxmlformats.org/presentationml/2006/main">
+  <p:cSld>
+    <p:spTree>
+      <p:nvGrpSpPr>
+        <p:cNvPr id="1" name=""/>
+        <p:cNvGrpSpPr/>
+        <p:nvPr/>
+      </p:nvGrpSpPr>
+      <p:grpSpPr>
+        <a:xfrm>
+          <a:off x="0" y="0"/>
+          <a:ext cx="0" cy="0"/>
+          <a:chOff x="0" y="0"/>
+          <a:chExt cx="0" cy="0"/>
+        </a:xfrm>
+      </p:grpSpPr>
+      <p:sp>
+        <p:nvSpPr>
+          <p:cNvPr id="2" name="Slide Image Placeholder 1"/>
+          <p:cNvSpPr>
+            <a:spLocks noGrp="1" noRot="1" noChangeAspect="1"/>
+          </p:cNvSpPr>
+          <p:nvPr>
+            <p:ph type="sldImg"/>
+          </p:nvPr>
+        </p:nvSpPr>
+        <p:spPr/>
+      </p:sp>
+      <p:sp>
+        <p:nvSpPr>
+          <p:cNvPr id="3" name="Notes Placeholder 2"/>
+          <p:cNvSpPr>
+            <a:spLocks noGrp="1"/>
+          </p:cNvSpPr>
+          <p:nvPr>
+            <p:ph type="body" idx="1"/>
+          </p:nvPr>
+        </p:nvSpPr>
+        <p:spPr/>
+        <p:txBody>
+          <a:bodyPr/>
+          <a:lstStyle/>
+          <a:p>
+            <a:r>
+              <a:rPr lang="en-US" dirty="0"/>
+              <a:t>Aufgabe 5. Überleitung: „Max Brods Brief war erfolgreich – der Vater hört zu. Jetzt spricht Franz selbst, und zwar offen.“ In der Stunde beginnen; ein bis zwei Reden werden in der nächsten Stunde ohne Unterbrechung vorgetragen und nach den Kriterien ausgewertet (keine Hausaufgabe). Hinweis: Substantive groß, Komma vor dass – auch bei „Ich hoffe, …“!</a:t>
+            </a:r>
+            <a:endParaRPr lang="en-US" dirty="0"/>
+          </a:p>
+        </p:txBody>
+      </p:sp>
+      <p:sp>
+        <p:nvSpPr>
+          <p:cNvPr id="4" name="Slide Number Placeholder 3"/>
+          <p:cNvSpPr>
+            <a:spLocks noGrp="1"/>
+          </p:cNvSpPr>
+          <p:nvPr>
+            <p:ph type="sldNum" sz="quarter" idx="10"/>
+          </p:nvPr>
+        </p:nvSpPr>
+        <p:spPr/>
+        <p:txBody>
+          <a:bodyPr/>
+          <a:lstStyle/>
+          <a:p>
+            <a:fld id="{F7021451-1387-4CA6-816F-3879F97B5CBC}" type="slidenum">
+              <a:rPr lang="en-US"/>
+              <a:t>16</a:t>
             </a:fld>
             <a:endParaRPr lang="en-US"/>
           </a:p>
@@ -1571,7 +1749,7 @@
           <a:p>
             <a:r>
               <a:rPr lang="en-US" dirty="0"/>
-              <a:t>Kurz an die letzte Stunde (Mentorin) anknüpfen: Selbstkundgabe, Brods Brief. Ziel der Stunde an die Tafel.</a:t>
+              <a:t>Zitat aus dem Material der Mentorin (dort leicht abweichend: „darin“ statt „dort ja“), hier nach dem Original. Achtung: „Mein Schreiben“ meint Kafkas Bücher, nicht den Brief – der Vater begrüßte sie mit „Legs auf den Nachttisch!“. Erwartung: Kafka kann nicht mit dem Vater reden („an Deiner Brust“ = Nähe, Vertrauen), deshalb schreibt er; die Beziehung ist gestört, der Sohn hat Furcht. Überleitung: Was will Kafka eigentlich von ihm?</a:t>
             </a:r>
             <a:endParaRPr lang="en-US" dirty="0"/>
           </a:p>
@@ -1659,7 +1837,7 @@
           <a:p>
             <a:r>
               <a:rPr lang="en-US" dirty="0"/>
-              <a:t>Steht auch auf dem Arbeitsblatt (2. Information). Rückbezug: „Mein Appell vorhin war verdeckt – ich habe nur beschrieben, was schlecht war.“</a:t>
+              <a:t>Kurz an die letzte Stunde (Mentorin) anknüpfen: Selbstkundgabe, Brods Brief. Ziel der Stunde an die Tafel.</a:t>
             </a:r>
             <a:endParaRPr lang="en-US" dirty="0"/>
           </a:p>
@@ -2342,7 +2520,7 @@
                 <a:ea typeface="Cambria" pitchFamily="34" charset="-122"/>
                 <a:cs typeface="Cambria" pitchFamily="34" charset="-120"/>
               </a:rPr>
-              <a:t>Worum bittet Kafka?</a:t>
+              <a:t>Information: Der Appell</a:t>
             </a:r>
             <a:endParaRPr lang="en-US" sz="3000" dirty="0"/>
           </a:p>
@@ -2389,29 +2567,62 @@
       </p:sp>
       <p:sp>
         <p:nvSpPr>
-          <p:cNvPr id="5" name="Text 3"/>
-          <p:cNvSpPr txBox="1"/>
-          <p:nvPr/>
-        </p:nvSpPr>
-        <p:spPr>
-          <a:xfrm>
-            <a:off x="457200" y="1143000"/>
-            <a:ext cx="11247120" cy="4937760"/>
-          </a:xfrm>
-          <a:prstGeom prst="rect">
-            <a:avLst/>
-          </a:prstGeom>
-          <a:noFill/>
-          <a:ln/>
-        </p:spPr>
-        <p:txBody>
-          <a:bodyPr wrap="square" lIns="0" tIns="0" rIns="0" bIns="0" rtlCol="0" anchor="t"/>
+          <p:cNvPr id="5" name="Shape 3"/>
+          <p:cNvSpPr/>
+          <p:nvPr/>
+        </p:nvSpPr>
+        <p:spPr>
+          <a:xfrm>
+            <a:off x="457200" y="1188720"/>
+            <a:ext cx="11247120" cy="1508760"/>
+          </a:xfrm>
+          <a:prstGeom prst="roundRect">
+            <a:avLst>
+              <a:gd name="adj" fmla="val 4848"/>
+            </a:avLst>
+          </a:prstGeom>
+          <a:solidFill>
+            <a:srgbClr val="FDECEA"/>
+          </a:solidFill>
+          <a:ln/>
+        </p:spPr>
+      </p:sp>
+      <p:sp>
+        <p:nvSpPr>
+          <p:cNvPr id="6" name="Text 4"/>
+          <p:cNvSpPr txBox="1"/>
+          <p:nvPr/>
+        </p:nvSpPr>
+        <p:spPr>
+          <a:xfrm>
+            <a:off x="731520" y="1188720"/>
+            <a:ext cx="10789920" cy="1508760"/>
+          </a:xfrm>
+          <a:prstGeom prst="rect">
+            <a:avLst/>
+          </a:prstGeom>
+          <a:noFill/>
+          <a:ln/>
+        </p:spPr>
+        <p:txBody>
+          <a:bodyPr wrap="square" lIns="0" tIns="0" rIns="0" bIns="0" rtlCol="0" anchor="ctr"/>
           <a:lstStyle/>
           <a:p>
             <a:pPr indent="0" marL="0">
-              <a:lnSpc>
-                <a:spcPct val="110000"/>
-              </a:lnSpc>
+              <a:buNone/>
+            </a:pPr>
+            <a:r>
+              <a:rPr lang="en-US" sz="2700" b="1" dirty="0">
+                <a:solidFill>
+                  <a:srgbClr val="D9534F"/>
+                </a:solidFill>
+                <a:latin typeface="Calibri" pitchFamily="34" charset="0"/>
+                <a:ea typeface="Calibri" pitchFamily="34" charset="-122"/>
+                <a:cs typeface="Calibri" pitchFamily="34" charset="-120"/>
+              </a:rPr>
+              <a:t>Appell: </a:t>
+            </a:r>
+            <a:pPr indent="0" marL="0">
               <a:buNone/>
             </a:pPr>
             <a:r>
@@ -2419,50 +2630,161 @@
                 <a:solidFill>
                   <a:srgbClr val="1E2761"/>
                 </a:solidFill>
-                <a:latin typeface="Cambria" pitchFamily="34" charset="0"/>
-                <a:ea typeface="Cambria" pitchFamily="34" charset="-122"/>
-                <a:cs typeface="Cambria" pitchFamily="34" charset="-120"/>
-              </a:rPr>
-              <a:t>Wobei ich Dich aber immerfort bitte, nicht zu vergessen, daß ich niemals im entferntesten an eine Schuld Deinerseits glaube. Du wirktest so auf mich, wie Du wirken mußtest, nur sollst Du aufhören, es für eine besondere Bosheit meinerseits zu halten, daß ich dieser Wirkung erlegen bin. […] ich kann nicht glauben, daß ein freundliches Wort, ein stilles Bei-der-Hand-Nehmen, ein guter Blick mir nicht alles hätten abfordern können, was man wollte.</a:t>
-            </a:r>
-            <a:endParaRPr lang="en-US" sz="2700" dirty="0"/>
-          </a:p>
-        </p:txBody>
-      </p:sp>
-      <p:sp>
-        <p:nvSpPr>
-          <p:cNvPr id="6" name="Text 4"/>
-          <p:cNvSpPr txBox="1"/>
-          <p:nvPr/>
-        </p:nvSpPr>
-        <p:spPr>
-          <a:xfrm>
-            <a:off x="457200" y="6263640"/>
-            <a:ext cx="11247120" cy="457200"/>
-          </a:xfrm>
-          <a:prstGeom prst="rect">
-            <a:avLst/>
-          </a:prstGeom>
-          <a:noFill/>
-          <a:ln/>
-        </p:spPr>
-        <p:txBody>
-          <a:bodyPr wrap="square" lIns="0" tIns="0" rIns="0" bIns="0" rtlCol="0" anchor="t"/>
-          <a:lstStyle/>
-          <a:p>
-            <a:pPr algn="r" indent="0" marL="0">
+                <a:latin typeface="Calibri" pitchFamily="34" charset="0"/>
+                <a:ea typeface="Calibri" pitchFamily="34" charset="-122"/>
+                <a:cs typeface="Calibri" pitchFamily="34" charset="-120"/>
+              </a:rPr>
+              <a:t>Mit dieser Seite einer Nachricht will der Sender erreichen, dass der Empfänger etwas tut, denkt oder fühlt.</a:t>
+            </a:r>
+            <a:endParaRPr lang="en-US" sz="2700" dirty="0"/>
+          </a:p>
+        </p:txBody>
+      </p:sp>
+      <p:sp>
+        <p:nvSpPr>
+          <p:cNvPr id="7" name="Shape 5"/>
+          <p:cNvSpPr/>
+          <p:nvPr/>
+        </p:nvSpPr>
+        <p:spPr>
+          <a:xfrm>
+            <a:off x="457200" y="2880360"/>
+            <a:ext cx="11247120" cy="1508760"/>
+          </a:xfrm>
+          <a:prstGeom prst="roundRect">
+            <a:avLst>
+              <a:gd name="adj" fmla="val 4848"/>
+            </a:avLst>
+          </a:prstGeom>
+          <a:solidFill>
+            <a:srgbClr val="F4F7FD"/>
+          </a:solidFill>
+          <a:ln/>
+        </p:spPr>
+      </p:sp>
+      <p:sp>
+        <p:nvSpPr>
+          <p:cNvPr id="8" name="Text 6"/>
+          <p:cNvSpPr txBox="1"/>
+          <p:nvPr/>
+        </p:nvSpPr>
+        <p:spPr>
+          <a:xfrm>
+            <a:off x="731520" y="2880360"/>
+            <a:ext cx="10789920" cy="1508760"/>
+          </a:xfrm>
+          <a:prstGeom prst="rect">
+            <a:avLst/>
+          </a:prstGeom>
+          <a:noFill/>
+          <a:ln/>
+        </p:spPr>
+        <p:txBody>
+          <a:bodyPr wrap="square" lIns="0" tIns="0" rIns="0" bIns="0" rtlCol="0" anchor="ctr"/>
+          <a:lstStyle/>
+          <a:p>
+            <a:pPr indent="0" marL="0">
+              <a:buNone/>
+            </a:pPr>
+            <a:r>
+              <a:rPr lang="en-US" sz="2700" b="1" dirty="0">
+                <a:solidFill>
+                  <a:srgbClr val="1E2761"/>
+                </a:solidFill>
+                <a:latin typeface="Calibri" pitchFamily="34" charset="0"/>
+                <a:ea typeface="Calibri" pitchFamily="34" charset="-122"/>
+                <a:cs typeface="Calibri" pitchFamily="34" charset="-120"/>
+              </a:rPr>
+              <a:t>offen: </a:t>
+            </a:r>
+            <a:pPr indent="0" marL="0">
               <a:buNone/>
             </a:pPr>
             <a:r>
               <a:rPr lang="en-US" sz="2700" dirty="0">
                 <a:solidFill>
-                  <a:srgbClr val="5B6B8C"/>
-                </a:solidFill>
-                <a:latin typeface="Calibri" pitchFamily="34" charset="0"/>
-                <a:ea typeface="Calibri" pitchFamily="34" charset="-122"/>
-                <a:cs typeface="Calibri" pitchFamily="34" charset="-120"/>
-              </a:rPr>
-              <a:t>Franz Kafka: „Brief an den Vater“ (1919), S. 3</a:t>
+                  <a:srgbClr val="1E2761"/>
+                </a:solidFill>
+                <a:latin typeface="Calibri" pitchFamily="34" charset="0"/>
+                <a:ea typeface="Calibri" pitchFamily="34" charset="-122"/>
+                <a:cs typeface="Calibri" pitchFamily="34" charset="-120"/>
+              </a:rPr>
+              <a:t>direkt ausgesprochen, z. B. als Bitte: „Hör mir bitte zu!“</a:t>
+            </a:r>
+            <a:endParaRPr lang="en-US" sz="2700" dirty="0"/>
+          </a:p>
+        </p:txBody>
+      </p:sp>
+      <p:sp>
+        <p:nvSpPr>
+          <p:cNvPr id="9" name="Shape 7"/>
+          <p:cNvSpPr/>
+          <p:nvPr/>
+        </p:nvSpPr>
+        <p:spPr>
+          <a:xfrm>
+            <a:off x="457200" y="4572000"/>
+            <a:ext cx="11247120" cy="1508760"/>
+          </a:xfrm>
+          <a:prstGeom prst="roundRect">
+            <a:avLst>
+              <a:gd name="adj" fmla="val 4848"/>
+            </a:avLst>
+          </a:prstGeom>
+          <a:solidFill>
+            <a:srgbClr val="F4F7FD"/>
+          </a:solidFill>
+          <a:ln/>
+        </p:spPr>
+      </p:sp>
+      <p:sp>
+        <p:nvSpPr>
+          <p:cNvPr id="10" name="Text 8"/>
+          <p:cNvSpPr txBox="1"/>
+          <p:nvPr/>
+        </p:nvSpPr>
+        <p:spPr>
+          <a:xfrm>
+            <a:off x="731520" y="4572000"/>
+            <a:ext cx="10789920" cy="1508760"/>
+          </a:xfrm>
+          <a:prstGeom prst="rect">
+            <a:avLst/>
+          </a:prstGeom>
+          <a:noFill/>
+          <a:ln/>
+        </p:spPr>
+        <p:txBody>
+          <a:bodyPr wrap="square" lIns="0" tIns="0" rIns="0" bIns="0" rtlCol="0" anchor="ctr"/>
+          <a:lstStyle/>
+          <a:p>
+            <a:pPr indent="0" marL="0">
+              <a:buNone/>
+            </a:pPr>
+            <a:r>
+              <a:rPr lang="en-US" sz="2700" b="1" dirty="0">
+                <a:solidFill>
+                  <a:srgbClr val="1E2761"/>
+                </a:solidFill>
+                <a:latin typeface="Calibri" pitchFamily="34" charset="0"/>
+                <a:ea typeface="Calibri" pitchFamily="34" charset="-122"/>
+                <a:cs typeface="Calibri" pitchFamily="34" charset="-120"/>
+              </a:rPr>
+              <a:t>verdeckt: </a:t>
+            </a:r>
+            <a:pPr indent="0" marL="0">
+              <a:buNone/>
+            </a:pPr>
+            <a:r>
+              <a:rPr lang="en-US" sz="2700" dirty="0">
+                <a:solidFill>
+                  <a:srgbClr val="1E2761"/>
+                </a:solidFill>
+                <a:latin typeface="Calibri" pitchFamily="34" charset="0"/>
+                <a:ea typeface="Calibri" pitchFamily="34" charset="-122"/>
+                <a:cs typeface="Calibri" pitchFamily="34" charset="-120"/>
+              </a:rPr>
+              <a:t>versteckt in einem Wunsch, einer Frage oder einer Beschreibung: „Du hörst mir nie zu.“</a:t>
             </a:r>
             <a:endParaRPr lang="en-US" sz="2700" dirty="0"/>
           </a:p>
@@ -2553,7 +2875,7 @@
                 <a:ea typeface="Cambria" pitchFamily="34" charset="-122"/>
                 <a:cs typeface="Cambria" pitchFamily="34" charset="-120"/>
               </a:rPr>
-              <a:t>Arbeitsblatt: Aufgaben 1–3</a:t>
+              <a:t>Worum bittet Kafka?</a:t>
             </a:r>
             <a:endParaRPr lang="en-US" sz="3000" dirty="0"/>
           </a:p>
@@ -2561,25 +2883,42 @@
       </p:sp>
       <p:sp>
         <p:nvSpPr>
-          <p:cNvPr id="4" name="Shape 2"/>
-          <p:cNvSpPr/>
-          <p:nvPr/>
-        </p:nvSpPr>
-        <p:spPr>
-          <a:xfrm>
-            <a:off x="9966960" y="137160"/>
-            <a:ext cx="1920240" cy="640080"/>
-          </a:xfrm>
-          <a:prstGeom prst="roundRect">
-            <a:avLst>
-              <a:gd name="adj" fmla="val 17143"/>
-            </a:avLst>
-          </a:prstGeom>
-          <a:solidFill>
-            <a:srgbClr val="D9534F"/>
-          </a:solidFill>
-          <a:ln/>
-        </p:spPr>
+          <p:cNvPr id="4" name="Text 2"/>
+          <p:cNvSpPr txBox="1"/>
+          <p:nvPr/>
+        </p:nvSpPr>
+        <p:spPr>
+          <a:xfrm>
+            <a:off x="8503920" y="137160"/>
+            <a:ext cx="3383280" cy="640080"/>
+          </a:xfrm>
+          <a:prstGeom prst="rect">
+            <a:avLst/>
+          </a:prstGeom>
+          <a:noFill/>
+          <a:ln/>
+        </p:spPr>
+        <p:txBody>
+          <a:bodyPr wrap="square" lIns="0" tIns="0" rIns="0" bIns="0" rtlCol="0" anchor="ctr"/>
+          <a:lstStyle/>
+          <a:p>
+            <a:pPr algn="r" indent="0" marL="0">
+              <a:buNone/>
+            </a:pPr>
+            <a:r>
+              <a:rPr lang="en-US" sz="2700" b="1" dirty="0">
+                <a:solidFill>
+                  <a:srgbClr val="CADCFC"/>
+                </a:solidFill>
+                <a:latin typeface="Calibri" pitchFamily="34" charset="0"/>
+                <a:ea typeface="Calibri" pitchFamily="34" charset="-122"/>
+                <a:cs typeface="Calibri" pitchFamily="34" charset="-120"/>
+              </a:rPr>
+              <a:t>INFORMIEREN</a:t>
+            </a:r>
+            <a:endParaRPr lang="en-US" sz="2700" dirty="0"/>
+          </a:p>
+        </p:txBody>
       </p:sp>
       <p:sp>
         <p:nvSpPr>
@@ -2589,103 +2928,62 @@
         </p:nvSpPr>
         <p:spPr>
           <a:xfrm>
-            <a:off x="9966960" y="137160"/>
-            <a:ext cx="1920240" cy="640080"/>
-          </a:xfrm>
-          <a:prstGeom prst="rect">
-            <a:avLst/>
-          </a:prstGeom>
-          <a:noFill/>
-          <a:ln/>
-        </p:spPr>
-        <p:txBody>
-          <a:bodyPr wrap="square" lIns="0" tIns="0" rIns="0" bIns="0" rtlCol="0" anchor="ctr"/>
-          <a:lstStyle/>
-          <a:p>
-            <a:pPr algn="ctr" indent="0" marL="0">
-              <a:buNone/>
-            </a:pPr>
-            <a:r>
-              <a:rPr lang="en-US" sz="2700" b="1" dirty="0">
-                <a:solidFill>
-                  <a:srgbClr val="FFFFFF"/>
-                </a:solidFill>
-                <a:latin typeface="Calibri" pitchFamily="34" charset="0"/>
-                <a:ea typeface="Calibri" pitchFamily="34" charset="-122"/>
-                <a:cs typeface="Calibri" pitchFamily="34" charset="-120"/>
-              </a:rPr>
-              <a:t>9 Min.</a:t>
-            </a:r>
-            <a:endParaRPr lang="en-US" sz="2700" dirty="0"/>
-          </a:p>
-        </p:txBody>
-      </p:sp>
-      <p:sp>
-        <p:nvSpPr>
-          <p:cNvPr id="6" name="Shape 4"/>
-          <p:cNvSpPr/>
-          <p:nvPr/>
-        </p:nvSpPr>
-        <p:spPr>
-          <a:xfrm>
-            <a:off x="457200" y="1234440"/>
-            <a:ext cx="11247120" cy="1280160"/>
-          </a:xfrm>
-          <a:prstGeom prst="roundRect">
-            <a:avLst>
-              <a:gd name="adj" fmla="val 5714"/>
-            </a:avLst>
-          </a:prstGeom>
-          <a:solidFill>
-            <a:srgbClr val="F4F7FD"/>
-          </a:solidFill>
-          <a:ln w="9525">
-            <a:solidFill>
-              <a:srgbClr val="D5DCEC"/>
-            </a:solidFill>
-            <a:prstDash val="solid"/>
-          </a:ln>
-        </p:spPr>
-      </p:sp>
-      <p:sp>
-        <p:nvSpPr>
-          <p:cNvPr id="7" name="Text 5"/>
-          <p:cNvSpPr txBox="1"/>
-          <p:nvPr/>
-        </p:nvSpPr>
-        <p:spPr>
-          <a:xfrm>
-            <a:off x="731520" y="1234440"/>
-            <a:ext cx="10789920" cy="1280160"/>
-          </a:xfrm>
-          <a:prstGeom prst="rect">
-            <a:avLst/>
-          </a:prstGeom>
-          <a:noFill/>
-          <a:ln/>
-        </p:spPr>
-        <p:txBody>
-          <a:bodyPr wrap="square" lIns="0" tIns="0" rIns="0" bIns="0" rtlCol="0" anchor="ctr"/>
+            <a:off x="457200" y="1143000"/>
+            <a:ext cx="11247120" cy="4937760"/>
+          </a:xfrm>
+          <a:prstGeom prst="rect">
+            <a:avLst/>
+          </a:prstGeom>
+          <a:noFill/>
+          <a:ln/>
+        </p:spPr>
+        <p:txBody>
+          <a:bodyPr wrap="square" lIns="0" tIns="0" rIns="0" bIns="0" rtlCol="0" anchor="t"/>
           <a:lstStyle/>
           <a:p>
             <a:pPr indent="0" marL="0">
-              <a:buNone/>
-            </a:pPr>
-            <a:r>
-              <a:rPr lang="en-US" sz="2700" b="1" dirty="0">
+              <a:lnSpc>
+                <a:spcPct val="110000"/>
+              </a:lnSpc>
+              <a:buNone/>
+            </a:pPr>
+            <a:r>
+              <a:rPr lang="en-US" sz="2700" dirty="0">
                 <a:solidFill>
                   <a:srgbClr val="1E2761"/>
                 </a:solidFill>
-                <a:latin typeface="Calibri" pitchFamily="34" charset="0"/>
-                <a:ea typeface="Calibri" pitchFamily="34" charset="-122"/>
-                <a:cs typeface="Calibri" pitchFamily="34" charset="-120"/>
-              </a:rPr>
-              <a:t>Aufgabe 1: Vorarbeit</a:t>
-            </a:r>
-            <a:endParaRPr lang="en-US" sz="2700" dirty="0"/>
-          </a:p>
-          <a:p>
-            <a:pPr indent="0" marL="0">
+                <a:latin typeface="Cambria" pitchFamily="34" charset="0"/>
+                <a:ea typeface="Cambria" pitchFamily="34" charset="-122"/>
+                <a:cs typeface="Cambria" pitchFamily="34" charset="-120"/>
+              </a:rPr>
+              <a:t>Wobei ich Dich aber immerfort bitte, nicht zu vergessen, daß ich niemals im entferntesten an eine Schuld Deinerseits glaube. Du wirktest so auf mich, wie Du wirken mußtest, nur sollst Du aufhören, es für eine besondere Bosheit meinerseits zu halten, daß ich dieser Wirkung erlegen bin. […] ich kann nicht glauben, daß ein freundliches Wort, ein stilles Bei-der-Hand-Nehmen, ein guter Blick mir nicht alles hätten abfordern können, was man wollte.</a:t>
+            </a:r>
+            <a:endParaRPr lang="en-US" sz="2700" dirty="0"/>
+          </a:p>
+        </p:txBody>
+      </p:sp>
+      <p:sp>
+        <p:nvSpPr>
+          <p:cNvPr id="6" name="Text 4"/>
+          <p:cNvSpPr txBox="1"/>
+          <p:nvPr/>
+        </p:nvSpPr>
+        <p:spPr>
+          <a:xfrm>
+            <a:off x="457200" y="6263640"/>
+            <a:ext cx="11247120" cy="457200"/>
+          </a:xfrm>
+          <a:prstGeom prst="rect">
+            <a:avLst/>
+          </a:prstGeom>
+          <a:noFill/>
+          <a:ln/>
+        </p:spPr>
+        <p:txBody>
+          <a:bodyPr wrap="square" lIns="0" tIns="0" rIns="0" bIns="0" rtlCol="0" anchor="t"/>
+          <a:lstStyle/>
+          <a:p>
+            <a:pPr algn="r" indent="0" marL="0">
               <a:buNone/>
             </a:pPr>
             <a:r>
@@ -2697,212 +2995,7 @@
                 <a:ea typeface="Calibri" pitchFamily="34" charset="-122"/>
                 <a:cs typeface="Calibri" pitchFamily="34" charset="-120"/>
               </a:rPr>
-              <a:t>Worum bittet Kafka? (ein Satz)</a:t>
-            </a:r>
-            <a:endParaRPr lang="en-US" sz="2700" dirty="0"/>
-          </a:p>
-        </p:txBody>
-      </p:sp>
-      <p:sp>
-        <p:nvSpPr>
-          <p:cNvPr id="8" name="Shape 6"/>
-          <p:cNvSpPr/>
-          <p:nvPr/>
-        </p:nvSpPr>
-        <p:spPr>
-          <a:xfrm>
-            <a:off x="457200" y="2697480"/>
-            <a:ext cx="11247120" cy="1280160"/>
-          </a:xfrm>
-          <a:prstGeom prst="roundRect">
-            <a:avLst>
-              <a:gd name="adj" fmla="val 5714"/>
-            </a:avLst>
-          </a:prstGeom>
-          <a:solidFill>
-            <a:srgbClr val="FFFFFF"/>
-          </a:solidFill>
-          <a:ln w="9525">
-            <a:solidFill>
-              <a:srgbClr val="D5DCEC"/>
-            </a:solidFill>
-            <a:prstDash val="solid"/>
-          </a:ln>
-        </p:spPr>
-      </p:sp>
-      <p:sp>
-        <p:nvSpPr>
-          <p:cNvPr id="9" name="Text 7"/>
-          <p:cNvSpPr txBox="1"/>
-          <p:nvPr/>
-        </p:nvSpPr>
-        <p:spPr>
-          <a:xfrm>
-            <a:off x="731520" y="2697480"/>
-            <a:ext cx="10789920" cy="1280160"/>
-          </a:xfrm>
-          <a:prstGeom prst="rect">
-            <a:avLst/>
-          </a:prstGeom>
-          <a:noFill/>
-          <a:ln/>
-        </p:spPr>
-        <p:txBody>
-          <a:bodyPr wrap="square" lIns="0" tIns="0" rIns="0" bIns="0" rtlCol="0" anchor="ctr"/>
-          <a:lstStyle/>
-          <a:p>
-            <a:pPr indent="0" marL="0">
-              <a:buNone/>
-            </a:pPr>
-            <a:r>
-              <a:rPr lang="en-US" sz="2700" b="1" dirty="0">
-                <a:solidFill>
-                  <a:srgbClr val="1E2761"/>
-                </a:solidFill>
-                <a:latin typeface="Calibri" pitchFamily="34" charset="0"/>
-                <a:ea typeface="Calibri" pitchFamily="34" charset="-122"/>
-                <a:cs typeface="Calibri" pitchFamily="34" charset="-120"/>
-              </a:rPr>
-              <a:t>Aufgabe 2: Analyse</a:t>
-            </a:r>
-            <a:endParaRPr lang="en-US" sz="2700" dirty="0"/>
-          </a:p>
-          <a:p>
-            <a:pPr indent="0" marL="0">
-              <a:buNone/>
-            </a:pPr>
-            <a:r>
-              <a:rPr lang="en-US" sz="2700" dirty="0">
-                <a:solidFill>
-                  <a:srgbClr val="5B6B8C"/>
-                </a:solidFill>
-                <a:latin typeface="Calibri" pitchFamily="34" charset="0"/>
-                <a:ea typeface="Calibri" pitchFamily="34" charset="-122"/>
-                <a:cs typeface="Calibri" pitchFamily="34" charset="-120"/>
-              </a:rPr>
-              <a:t>drei Leitfragen, mit Zitat und Zeile</a:t>
-            </a:r>
-            <a:endParaRPr lang="en-US" sz="2700" dirty="0"/>
-          </a:p>
-        </p:txBody>
-      </p:sp>
-      <p:sp>
-        <p:nvSpPr>
-          <p:cNvPr id="10" name="Shape 8"/>
-          <p:cNvSpPr/>
-          <p:nvPr/>
-        </p:nvSpPr>
-        <p:spPr>
-          <a:xfrm>
-            <a:off x="457200" y="4160520"/>
-            <a:ext cx="11247120" cy="1280160"/>
-          </a:xfrm>
-          <a:prstGeom prst="roundRect">
-            <a:avLst>
-              <a:gd name="adj" fmla="val 5714"/>
-            </a:avLst>
-          </a:prstGeom>
-          <a:solidFill>
-            <a:srgbClr val="F4F7FD"/>
-          </a:solidFill>
-          <a:ln w="9525">
-            <a:solidFill>
-              <a:srgbClr val="D5DCEC"/>
-            </a:solidFill>
-            <a:prstDash val="solid"/>
-          </a:ln>
-        </p:spPr>
-      </p:sp>
-      <p:sp>
-        <p:nvSpPr>
-          <p:cNvPr id="11" name="Text 9"/>
-          <p:cNvSpPr txBox="1"/>
-          <p:nvPr/>
-        </p:nvSpPr>
-        <p:spPr>
-          <a:xfrm>
-            <a:off x="731520" y="4160520"/>
-            <a:ext cx="10789920" cy="1280160"/>
-          </a:xfrm>
-          <a:prstGeom prst="rect">
-            <a:avLst/>
-          </a:prstGeom>
-          <a:noFill/>
-          <a:ln/>
-        </p:spPr>
-        <p:txBody>
-          <a:bodyPr wrap="square" lIns="0" tIns="0" rIns="0" bIns="0" rtlCol="0" anchor="ctr"/>
-          <a:lstStyle/>
-          <a:p>
-            <a:pPr indent="0" marL="0">
-              <a:buNone/>
-            </a:pPr>
-            <a:r>
-              <a:rPr lang="en-US" sz="2700" b="1" dirty="0">
-                <a:solidFill>
-                  <a:srgbClr val="1E2761"/>
-                </a:solidFill>
-                <a:latin typeface="Calibri" pitchFamily="34" charset="0"/>
-                <a:ea typeface="Calibri" pitchFamily="34" charset="-122"/>
-                <a:cs typeface="Calibri" pitchFamily="34" charset="-120"/>
-              </a:rPr>
-              <a:t>Aufgabe 3: Visualisierung</a:t>
-            </a:r>
-            <a:endParaRPr lang="en-US" sz="2700" dirty="0"/>
-          </a:p>
-          <a:p>
-            <a:pPr indent="0" marL="0">
-              <a:buNone/>
-            </a:pPr>
-            <a:r>
-              <a:rPr lang="en-US" sz="2700" dirty="0">
-                <a:solidFill>
-                  <a:srgbClr val="5B6B8C"/>
-                </a:solidFill>
-                <a:latin typeface="Calibri" pitchFamily="34" charset="0"/>
-                <a:ea typeface="Calibri" pitchFamily="34" charset="-122"/>
-                <a:cs typeface="Calibri" pitchFamily="34" charset="-120"/>
-              </a:rPr>
-              <a:t>Kommunikationsquadrat, Fokus Appell</a:t>
-            </a:r>
-            <a:endParaRPr lang="en-US" sz="2700" dirty="0"/>
-          </a:p>
-        </p:txBody>
-      </p:sp>
-      <p:sp>
-        <p:nvSpPr>
-          <p:cNvPr id="12" name="Text 10"/>
-          <p:cNvSpPr txBox="1"/>
-          <p:nvPr/>
-        </p:nvSpPr>
-        <p:spPr>
-          <a:xfrm>
-            <a:off x="457200" y="5760720"/>
-            <a:ext cx="11247120" cy="548640"/>
-          </a:xfrm>
-          <a:prstGeom prst="rect">
-            <a:avLst/>
-          </a:prstGeom>
-          <a:noFill/>
-          <a:ln/>
-        </p:spPr>
-        <p:txBody>
-          <a:bodyPr wrap="square" lIns="0" tIns="0" rIns="0" bIns="0" rtlCol="0" anchor="t"/>
-          <a:lstStyle/>
-          <a:p>
-            <a:pPr indent="0" marL="0">
-              <a:buNone/>
-            </a:pPr>
-            <a:r>
-              <a:rPr lang="en-US" sz="2700" i="1" dirty="0">
-                <a:solidFill>
-                  <a:srgbClr val="5B6B8C"/>
-                </a:solidFill>
-                <a:latin typeface="Calibri" pitchFamily="34" charset="0"/>
-                <a:ea typeface="Calibri" pitchFamily="34" charset="-122"/>
-                <a:cs typeface="Calibri" pitchFamily="34" charset="-120"/>
-              </a:rPr>
-              <a:t>Allein, direkt auf dem Arbeitsblatt. Formulierungshilfen stehen dort.</a:t>
+              <a:t>Franz Kafka: „Brief an den Vater“ (1919), S. 3</a:t>
             </a:r>
             <a:endParaRPr lang="en-US" sz="2700" dirty="0"/>
           </a:p>
@@ -2993,7 +3086,7 @@
                 <a:ea typeface="Cambria" pitchFamily="34" charset="-122"/>
                 <a:cs typeface="Cambria" pitchFamily="34" charset="-120"/>
               </a:rPr>
-              <a:t>Formulierungshilfen</a:t>
+              <a:t>Aufgabe 1: Vorarbeit</a:t>
             </a:r>
             <a:endParaRPr lang="en-US" sz="3000" dirty="0"/>
           </a:p>
@@ -3001,14 +3094,36 @@
       </p:sp>
       <p:sp>
         <p:nvSpPr>
-          <p:cNvPr id="4" name="Text 2"/>
-          <p:cNvSpPr txBox="1"/>
-          <p:nvPr/>
-        </p:nvSpPr>
-        <p:spPr>
-          <a:xfrm>
-            <a:off x="8503920" y="137160"/>
-            <a:ext cx="3383280" cy="640080"/>
+          <p:cNvPr id="4" name="Shape 2"/>
+          <p:cNvSpPr/>
+          <p:nvPr/>
+        </p:nvSpPr>
+        <p:spPr>
+          <a:xfrm>
+            <a:off x="9966960" y="137160"/>
+            <a:ext cx="1920240" cy="640080"/>
+          </a:xfrm>
+          <a:prstGeom prst="roundRect">
+            <a:avLst>
+              <a:gd name="adj" fmla="val 17143"/>
+            </a:avLst>
+          </a:prstGeom>
+          <a:solidFill>
+            <a:srgbClr val="D9534F"/>
+          </a:solidFill>
+          <a:ln/>
+        </p:spPr>
+      </p:sp>
+      <p:sp>
+        <p:nvSpPr>
+          <p:cNvPr id="5" name="Text 3"/>
+          <p:cNvSpPr txBox="1"/>
+          <p:nvPr/>
+        </p:nvSpPr>
+        <p:spPr>
+          <a:xfrm>
+            <a:off x="9966960" y="137160"/>
+            <a:ext cx="1920240" cy="640080"/>
           </a:xfrm>
           <a:prstGeom prst="rect">
             <a:avLst/>
@@ -3020,34 +3135,95 @@
           <a:bodyPr wrap="square" lIns="0" tIns="0" rIns="0" bIns="0" rtlCol="0" anchor="ctr"/>
           <a:lstStyle/>
           <a:p>
-            <a:pPr algn="r" indent="0" marL="0">
+            <a:pPr algn="ctr" indent="0" marL="0">
               <a:buNone/>
             </a:pPr>
             <a:r>
               <a:rPr lang="en-US" sz="2700" b="1" dirty="0">
                 <a:solidFill>
-                  <a:srgbClr val="CADCFC"/>
-                </a:solidFill>
-                <a:latin typeface="Calibri" pitchFamily="34" charset="0"/>
-                <a:ea typeface="Calibri" pitchFamily="34" charset="-122"/>
-                <a:cs typeface="Calibri" pitchFamily="34" charset="-120"/>
-              </a:rPr>
-              <a:t>AUSWERTEN</a:t>
-            </a:r>
-            <a:endParaRPr lang="en-US" sz="2700" dirty="0"/>
-          </a:p>
-        </p:txBody>
-      </p:sp>
-      <p:sp>
-        <p:nvSpPr>
-          <p:cNvPr id="5" name="Text 3"/>
-          <p:cNvSpPr txBox="1"/>
-          <p:nvPr/>
-        </p:nvSpPr>
-        <p:spPr>
-          <a:xfrm>
-            <a:off x="731520" y="1280160"/>
-            <a:ext cx="10789920" cy="4572000"/>
+                  <a:srgbClr val="FFFFFF"/>
+                </a:solidFill>
+                <a:latin typeface="Calibri" pitchFamily="34" charset="0"/>
+                <a:ea typeface="Calibri" pitchFamily="34" charset="-122"/>
+                <a:cs typeface="Calibri" pitchFamily="34" charset="-120"/>
+              </a:rPr>
+              <a:t>3 Min.</a:t>
+            </a:r>
+            <a:endParaRPr lang="en-US" sz="2700" dirty="0"/>
+          </a:p>
+        </p:txBody>
+      </p:sp>
+      <p:sp>
+        <p:nvSpPr>
+          <p:cNvPr id="6" name="Shape 4"/>
+          <p:cNvSpPr/>
+          <p:nvPr/>
+        </p:nvSpPr>
+        <p:spPr>
+          <a:xfrm>
+            <a:off x="457200" y="1143000"/>
+            <a:ext cx="11247120" cy="1188720"/>
+          </a:xfrm>
+          <a:prstGeom prst="roundRect">
+            <a:avLst>
+              <a:gd name="adj" fmla="val 6154"/>
+            </a:avLst>
+          </a:prstGeom>
+          <a:solidFill>
+            <a:srgbClr val="F4F7FD"/>
+          </a:solidFill>
+          <a:ln/>
+        </p:spPr>
+      </p:sp>
+      <p:sp>
+        <p:nvSpPr>
+          <p:cNvPr id="7" name="Text 5"/>
+          <p:cNvSpPr txBox="1"/>
+          <p:nvPr/>
+        </p:nvSpPr>
+        <p:spPr>
+          <a:xfrm>
+            <a:off x="731520" y="1143000"/>
+            <a:ext cx="10789920" cy="1188720"/>
+          </a:xfrm>
+          <a:prstGeom prst="rect">
+            <a:avLst/>
+          </a:prstGeom>
+          <a:noFill/>
+          <a:ln/>
+        </p:spPr>
+        <p:txBody>
+          <a:bodyPr wrap="square" lIns="0" tIns="0" rIns="0" bIns="0" rtlCol="0" anchor="ctr"/>
+          <a:lstStyle/>
+          <a:p>
+            <a:pPr indent="0" marL="0">
+              <a:buNone/>
+            </a:pPr>
+            <a:r>
+              <a:rPr lang="en-US" sz="2700" b="1" dirty="0">
+                <a:solidFill>
+                  <a:srgbClr val="1E2761"/>
+                </a:solidFill>
+                <a:latin typeface="Calibri" pitchFamily="34" charset="0"/>
+                <a:ea typeface="Calibri" pitchFamily="34" charset="-122"/>
+                <a:cs typeface="Calibri" pitchFamily="34" charset="-120"/>
+              </a:rPr>
+              <a:t>Fasse den Auszug in einem Satz zusammen: Worum bittet Kafka seinen Vater?</a:t>
+            </a:r>
+            <a:endParaRPr lang="en-US" sz="2700" dirty="0"/>
+          </a:p>
+        </p:txBody>
+      </p:sp>
+      <p:sp>
+        <p:nvSpPr>
+          <p:cNvPr id="8" name="Text 6"/>
+          <p:cNvSpPr txBox="1"/>
+          <p:nvPr/>
+        </p:nvSpPr>
+        <p:spPr>
+          <a:xfrm>
+            <a:off x="731520" y="2743200"/>
+            <a:ext cx="10789920" cy="731520"/>
           </a:xfrm>
           <a:prstGeom prst="rect">
             <a:avLst/>
@@ -3059,86 +3235,58 @@
           <a:bodyPr wrap="square" lIns="0" tIns="0" rIns="0" bIns="0" rtlCol="0" anchor="t"/>
           <a:lstStyle/>
           <a:p>
-            <a:pPr marL="304800" indent="-304800">
-              <a:spcAft>
-                <a:spcPts val="1600"/>
-              </a:spcAft>
-              <a:buSzPct val="100000"/>
-              <a:buChar char="•"/>
+            <a:pPr indent="0" marL="0">
+              <a:buNone/>
             </a:pPr>
             <a:r>
               <a:rPr lang="en-US" sz="2700" i="1" dirty="0">
                 <a:solidFill>
-                  <a:srgbClr val="1E2761"/>
-                </a:solidFill>
-                <a:latin typeface="Calibri" pitchFamily="34" charset="0"/>
-                <a:ea typeface="Calibri" pitchFamily="34" charset="-122"/>
-                <a:cs typeface="Calibri" pitchFamily="34" charset="-120"/>
-              </a:rPr>
-              <a:t>Ein offener Appell zeigt sich in … (Z. …).</a:t>
-            </a:r>
-            <a:endParaRPr lang="en-US" sz="2700" dirty="0"/>
-          </a:p>
-          <a:p>
-            <a:pPr marL="304800" indent="-304800">
-              <a:spcAft>
-                <a:spcPts val="1600"/>
-              </a:spcAft>
-              <a:buSzPct val="100000"/>
-              <a:buChar char="•"/>
+                  <a:srgbClr val="5B6B8C"/>
+                </a:solidFill>
+                <a:latin typeface="Calibri" pitchFamily="34" charset="0"/>
+                <a:ea typeface="Calibri" pitchFamily="34" charset="-122"/>
+                <a:cs typeface="Calibri" pitchFamily="34" charset="-120"/>
+              </a:rPr>
+              <a:t>Satzanfang:  „Kafka bittet seinen Vater, …“</a:t>
+            </a:r>
+            <a:endParaRPr lang="en-US" sz="2700" dirty="0"/>
+          </a:p>
+        </p:txBody>
+      </p:sp>
+      <p:sp>
+        <p:nvSpPr>
+          <p:cNvPr id="9" name="Text 7"/>
+          <p:cNvSpPr txBox="1"/>
+          <p:nvPr/>
+        </p:nvSpPr>
+        <p:spPr>
+          <a:xfrm>
+            <a:off x="457200" y="6172200"/>
+            <a:ext cx="11247120" cy="502920"/>
+          </a:xfrm>
+          <a:prstGeom prst="rect">
+            <a:avLst/>
+          </a:prstGeom>
+          <a:noFill/>
+          <a:ln/>
+        </p:spPr>
+        <p:txBody>
+          <a:bodyPr wrap="square" lIns="0" tIns="0" rIns="0" bIns="0" rtlCol="0" anchor="t"/>
+          <a:lstStyle/>
+          <a:p>
+            <a:pPr indent="0" marL="0">
+              <a:buNone/>
             </a:pPr>
             <a:r>
               <a:rPr lang="en-US" sz="2700" i="1" dirty="0">
                 <a:solidFill>
-                  <a:srgbClr val="1E2761"/>
-                </a:solidFill>
-                <a:latin typeface="Calibri" pitchFamily="34" charset="0"/>
-                <a:ea typeface="Calibri" pitchFamily="34" charset="-122"/>
-                <a:cs typeface="Calibri" pitchFamily="34" charset="-120"/>
-              </a:rPr>
-              <a:t>Verdeckt appelliert Kafka, wenn er …</a:t>
-            </a:r>
-            <a:endParaRPr lang="en-US" sz="2700" dirty="0"/>
-          </a:p>
-          <a:p>
-            <a:pPr marL="304800" indent="-304800">
-              <a:spcAft>
-                <a:spcPts val="1600"/>
-              </a:spcAft>
-              <a:buSzPct val="100000"/>
-              <a:buChar char="•"/>
-            </a:pPr>
-            <a:r>
-              <a:rPr lang="en-US" sz="2700" i="1" dirty="0">
-                <a:solidFill>
-                  <a:srgbClr val="1E2761"/>
-                </a:solidFill>
-                <a:latin typeface="Calibri" pitchFamily="34" charset="0"/>
-                <a:ea typeface="Calibri" pitchFamily="34" charset="-122"/>
-                <a:cs typeface="Calibri" pitchFamily="34" charset="-120"/>
-              </a:rPr>
-              <a:t>Damit will er erreichen, dass der Vater …</a:t>
-            </a:r>
-            <a:endParaRPr lang="en-US" sz="2700" dirty="0"/>
-          </a:p>
-          <a:p>
-            <a:pPr marL="304800" indent="-304800">
-              <a:spcAft>
-                <a:spcPts val="1600"/>
-              </a:spcAft>
-              <a:buSzPct val="100000"/>
-              <a:buChar char="•"/>
-            </a:pPr>
-            <a:r>
-              <a:rPr lang="en-US" sz="2700" i="1" dirty="0">
-                <a:solidFill>
-                  <a:srgbClr val="1E2761"/>
-                </a:solidFill>
-                <a:latin typeface="Calibri" pitchFamily="34" charset="0"/>
-                <a:ea typeface="Calibri" pitchFamily="34" charset="-122"/>
-                <a:cs typeface="Calibri" pitchFamily="34" charset="-120"/>
-              </a:rPr>
-              <a:t>Seine Bitte sichert er ab, indem er …</a:t>
+                  <a:srgbClr val="5B6B8C"/>
+                </a:solidFill>
+                <a:latin typeface="Calibri" pitchFamily="34" charset="0"/>
+                <a:ea typeface="Calibri" pitchFamily="34" charset="-122"/>
+                <a:cs typeface="Calibri" pitchFamily="34" charset="-120"/>
+              </a:rPr>
+              <a:t>Allein, direkt auf dem Arbeitsblatt.</a:t>
             </a:r>
             <a:endParaRPr lang="en-US" sz="2700" dirty="0"/>
           </a:p>
@@ -3158,7 +3306,7 @@
     <p:bg>
       <p:bgPr>
         <a:solidFill>
-          <a:srgbClr val="1E2761"/>
+          <a:srgbClr val="FFFFFF"/>
         </a:solidFill>
       </p:bgPr>
     </p:bg>
@@ -3184,32 +3332,71 @@
         </p:nvSpPr>
         <p:spPr>
           <a:xfrm>
-            <a:off x="9692640" y="-1463040"/>
-            <a:ext cx="4206240" cy="4206240"/>
-          </a:xfrm>
-          <a:prstGeom prst="ellipse">
+            <a:off x="0" y="0"/>
+            <a:ext cx="12191695" cy="914400"/>
+          </a:xfrm>
+          <a:prstGeom prst="roundRect">
             <a:avLst/>
           </a:prstGeom>
           <a:solidFill>
-            <a:srgbClr val="24306E"/>
+            <a:srgbClr val="1E2761"/>
           </a:solidFill>
           <a:ln/>
         </p:spPr>
       </p:sp>
       <p:sp>
         <p:nvSpPr>
-          <p:cNvPr id="3" name="Shape 1"/>
+          <p:cNvPr id="3" name="Text 1"/>
+          <p:cNvSpPr txBox="1"/>
+          <p:nvPr/>
+        </p:nvSpPr>
+        <p:spPr>
+          <a:xfrm>
+            <a:off x="457200" y="0"/>
+            <a:ext cx="9326880" cy="914400"/>
+          </a:xfrm>
+          <a:prstGeom prst="rect">
+            <a:avLst/>
+          </a:prstGeom>
+          <a:noFill/>
+          <a:ln/>
+        </p:spPr>
+        <p:txBody>
+          <a:bodyPr wrap="square" lIns="0" tIns="0" rIns="0" bIns="0" rtlCol="0" anchor="ctr"/>
+          <a:lstStyle/>
+          <a:p>
+            <a:pPr indent="0" marL="0">
+              <a:buNone/>
+            </a:pPr>
+            <a:r>
+              <a:rPr lang="en-US" sz="3000" b="1" dirty="0">
+                <a:solidFill>
+                  <a:srgbClr val="FFFFFF"/>
+                </a:solidFill>
+                <a:latin typeface="Cambria" pitchFamily="34" charset="0"/>
+                <a:ea typeface="Cambria" pitchFamily="34" charset="-122"/>
+                <a:cs typeface="Cambria" pitchFamily="34" charset="-120"/>
+              </a:rPr>
+              <a:t>Aufgabe 2: Analyse</a:t>
+            </a:r>
+            <a:endParaRPr lang="en-US" sz="3000" dirty="0"/>
+          </a:p>
+        </p:txBody>
+      </p:sp>
+      <p:sp>
+        <p:nvSpPr>
+          <p:cNvPr id="4" name="Shape 2"/>
           <p:cNvSpPr/>
           <p:nvPr/>
         </p:nvSpPr>
         <p:spPr>
           <a:xfrm>
-            <a:off x="822960" y="1280160"/>
-            <a:ext cx="2926080" cy="548640"/>
+            <a:off x="9966960" y="137160"/>
+            <a:ext cx="1920240" cy="640080"/>
           </a:xfrm>
           <a:prstGeom prst="roundRect">
             <a:avLst>
-              <a:gd name="adj" fmla="val 50000"/>
+              <a:gd name="adj" fmla="val 17143"/>
             </a:avLst>
           </a:prstGeom>
           <a:solidFill>
@@ -3220,14 +3407,14 @@
       </p:sp>
       <p:sp>
         <p:nvSpPr>
-          <p:cNvPr id="4" name="Text 2"/>
-          <p:cNvSpPr txBox="1"/>
-          <p:nvPr/>
-        </p:nvSpPr>
-        <p:spPr>
-          <a:xfrm>
-            <a:off x="822960" y="1280160"/>
-            <a:ext cx="2926080" cy="548640"/>
+          <p:cNvPr id="5" name="Text 3"/>
+          <p:cNvSpPr txBox="1"/>
+          <p:nvPr/>
+        </p:nvSpPr>
+        <p:spPr>
+          <a:xfrm>
+            <a:off x="9966960" y="137160"/>
+            <a:ext cx="1920240" cy="640080"/>
           </a:xfrm>
           <a:prstGeom prst="rect">
             <a:avLst/>
@@ -3251,22 +3438,105 @@
                 <a:ea typeface="Calibri" pitchFamily="34" charset="-122"/>
                 <a:cs typeface="Calibri" pitchFamily="34" charset="-120"/>
               </a:rPr>
-              <a:t>REFLEXION</a:t>
-            </a:r>
-            <a:endParaRPr lang="en-US" sz="2700" dirty="0"/>
-          </a:p>
-        </p:txBody>
-      </p:sp>
-      <p:sp>
-        <p:nvSpPr>
-          <p:cNvPr id="5" name="Text 3"/>
-          <p:cNvSpPr txBox="1"/>
-          <p:nvPr/>
-        </p:nvSpPr>
-        <p:spPr>
-          <a:xfrm>
-            <a:off x="822960" y="2194560"/>
-            <a:ext cx="10424160" cy="822960"/>
+              <a:t>6 Min.</a:t>
+            </a:r>
+            <a:endParaRPr lang="en-US" sz="2700" dirty="0"/>
+          </a:p>
+        </p:txBody>
+      </p:sp>
+      <p:sp>
+        <p:nvSpPr>
+          <p:cNvPr id="6" name="Shape 4"/>
+          <p:cNvSpPr/>
+          <p:nvPr/>
+        </p:nvSpPr>
+        <p:spPr>
+          <a:xfrm>
+            <a:off x="457200" y="1143000"/>
+            <a:ext cx="11247120" cy="1188720"/>
+          </a:xfrm>
+          <a:prstGeom prst="roundRect">
+            <a:avLst>
+              <a:gd name="adj" fmla="val 6154"/>
+            </a:avLst>
+          </a:prstGeom>
+          <a:solidFill>
+            <a:srgbClr val="F4F7FD"/>
+          </a:solidFill>
+          <a:ln/>
+        </p:spPr>
+      </p:sp>
+      <p:sp>
+        <p:nvSpPr>
+          <p:cNvPr id="7" name="Text 5"/>
+          <p:cNvSpPr txBox="1"/>
+          <p:nvPr/>
+        </p:nvSpPr>
+        <p:spPr>
+          <a:xfrm>
+            <a:off x="731520" y="1143000"/>
+            <a:ext cx="10789920" cy="1188720"/>
+          </a:xfrm>
+          <a:prstGeom prst="rect">
+            <a:avLst/>
+          </a:prstGeom>
+          <a:noFill/>
+          <a:ln/>
+        </p:spPr>
+        <p:txBody>
+          <a:bodyPr wrap="square" lIns="0" tIns="0" rIns="0" bIns="0" rtlCol="0" anchor="ctr"/>
+          <a:lstStyle/>
+          <a:p>
+            <a:pPr indent="0" marL="0">
+              <a:buNone/>
+            </a:pPr>
+            <a:r>
+              <a:rPr lang="en-US" sz="2700" b="1" dirty="0">
+                <a:solidFill>
+                  <a:srgbClr val="1E2761"/>
+                </a:solidFill>
+                <a:latin typeface="Calibri" pitchFamily="34" charset="0"/>
+                <a:ea typeface="Calibri" pitchFamily="34" charset="-122"/>
+                <a:cs typeface="Calibri" pitchFamily="34" charset="-120"/>
+              </a:rPr>
+              <a:t>Beantworte die drei Leitfragen – mit Zitat und Zeile.</a:t>
+            </a:r>
+            <a:endParaRPr lang="en-US" sz="2700" dirty="0"/>
+          </a:p>
+        </p:txBody>
+      </p:sp>
+      <p:sp>
+        <p:nvSpPr>
+          <p:cNvPr id="8" name="Shape 6"/>
+          <p:cNvSpPr/>
+          <p:nvPr/>
+        </p:nvSpPr>
+        <p:spPr>
+          <a:xfrm>
+            <a:off x="457200" y="2560320"/>
+            <a:ext cx="11247120" cy="3474720"/>
+          </a:xfrm>
+          <a:prstGeom prst="roundRect">
+            <a:avLst>
+              <a:gd name="adj" fmla="val 2105"/>
+            </a:avLst>
+          </a:prstGeom>
+          <a:solidFill>
+            <a:srgbClr val="FFF8EC"/>
+          </a:solidFill>
+          <a:ln/>
+        </p:spPr>
+      </p:sp>
+      <p:sp>
+        <p:nvSpPr>
+          <p:cNvPr id="9" name="Text 7"/>
+          <p:cNvSpPr txBox="1"/>
+          <p:nvPr/>
+        </p:nvSpPr>
+        <p:spPr>
+          <a:xfrm>
+            <a:off x="731520" y="2651760"/>
+            <a:ext cx="10789920" cy="548640"/>
           </a:xfrm>
           <a:prstGeom prst="rect">
             <a:avLst/>
@@ -3282,30 +3552,30 @@
               <a:buNone/>
             </a:pPr>
             <a:r>
-              <a:rPr lang="en-US" sz="3200" b="1" dirty="0">
-                <a:solidFill>
-                  <a:srgbClr val="FFFFFF"/>
+              <a:rPr lang="en-US" sz="2700" b="1" dirty="0">
+                <a:solidFill>
+                  <a:srgbClr val="E8A33D"/>
                 </a:solidFill>
                 <a:latin typeface="Cambria" pitchFamily="34" charset="0"/>
                 <a:ea typeface="Cambria" pitchFamily="34" charset="-122"/>
                 <a:cs typeface="Cambria" pitchFamily="34" charset="-120"/>
               </a:rPr>
-              <a:t>Kafka hat den Brief nie übergeben.</a:t>
-            </a:r>
-            <a:endParaRPr lang="en-US" sz="3200" dirty="0"/>
-          </a:p>
-        </p:txBody>
-      </p:sp>
-      <p:sp>
-        <p:nvSpPr>
-          <p:cNvPr id="6" name="Text 4"/>
-          <p:cNvSpPr txBox="1"/>
-          <p:nvPr/>
-        </p:nvSpPr>
-        <p:spPr>
-          <a:xfrm>
-            <a:off x="822960" y="3291840"/>
-            <a:ext cx="10424160" cy="2377440"/>
+              <a:t>Formulierungshilfen</a:t>
+            </a:r>
+            <a:endParaRPr lang="en-US" sz="2700" dirty="0"/>
+          </a:p>
+        </p:txBody>
+      </p:sp>
+      <p:sp>
+        <p:nvSpPr>
+          <p:cNvPr id="10" name="Text 8"/>
+          <p:cNvSpPr txBox="1"/>
+          <p:nvPr/>
+        </p:nvSpPr>
+        <p:spPr>
+          <a:xfrm>
+            <a:off x="731520" y="3200400"/>
+            <a:ext cx="10789920" cy="2743200"/>
           </a:xfrm>
           <a:prstGeom prst="rect">
             <a:avLst/>
@@ -3317,42 +3587,125 @@
           <a:bodyPr wrap="square" lIns="0" tIns="0" rIns="0" bIns="0" rtlCol="0" anchor="t"/>
           <a:lstStyle/>
           <a:p>
+            <a:pPr marL="304800" indent="-304800">
+              <a:spcAft>
+                <a:spcPts val="800"/>
+              </a:spcAft>
+              <a:buSzPct val="100000"/>
+              <a:buChar char="•"/>
+            </a:pPr>
+            <a:r>
+              <a:rPr lang="en-US" sz="2700" i="1" dirty="0">
+                <a:solidFill>
+                  <a:srgbClr val="1E2761"/>
+                </a:solidFill>
+                <a:latin typeface="Calibri" pitchFamily="34" charset="0"/>
+                <a:ea typeface="Calibri" pitchFamily="34" charset="-122"/>
+                <a:cs typeface="Calibri" pitchFamily="34" charset="-120"/>
+              </a:rPr>
+              <a:t>Ein offener Appell zeigt sich in … (Z. …).</a:t>
+            </a:r>
+            <a:endParaRPr lang="en-US" sz="2700" dirty="0"/>
+          </a:p>
+          <a:p>
+            <a:pPr marL="304800" indent="-304800">
+              <a:spcAft>
+                <a:spcPts val="800"/>
+              </a:spcAft>
+              <a:buSzPct val="100000"/>
+              <a:buChar char="•"/>
+            </a:pPr>
+            <a:r>
+              <a:rPr lang="en-US" sz="2700" i="1" dirty="0">
+                <a:solidFill>
+                  <a:srgbClr val="1E2761"/>
+                </a:solidFill>
+                <a:latin typeface="Calibri" pitchFamily="34" charset="0"/>
+                <a:ea typeface="Calibri" pitchFamily="34" charset="-122"/>
+                <a:cs typeface="Calibri" pitchFamily="34" charset="-120"/>
+              </a:rPr>
+              <a:t>Verdeckt appelliert Kafka, wenn er …</a:t>
+            </a:r>
+            <a:endParaRPr lang="en-US" sz="2700" dirty="0"/>
+          </a:p>
+          <a:p>
+            <a:pPr marL="304800" indent="-304800">
+              <a:spcAft>
+                <a:spcPts val="800"/>
+              </a:spcAft>
+              <a:buSzPct val="100000"/>
+              <a:buChar char="•"/>
+            </a:pPr>
+            <a:r>
+              <a:rPr lang="en-US" sz="2700" i="1" dirty="0">
+                <a:solidFill>
+                  <a:srgbClr val="1E2761"/>
+                </a:solidFill>
+                <a:latin typeface="Calibri" pitchFamily="34" charset="0"/>
+                <a:ea typeface="Calibri" pitchFamily="34" charset="-122"/>
+                <a:cs typeface="Calibri" pitchFamily="34" charset="-120"/>
+              </a:rPr>
+              <a:t>Damit will er erreichen, dass der Vater …</a:t>
+            </a:r>
+            <a:endParaRPr lang="en-US" sz="2700" dirty="0"/>
+          </a:p>
+          <a:p>
+            <a:pPr marL="304800" indent="-304800">
+              <a:spcAft>
+                <a:spcPts val="800"/>
+              </a:spcAft>
+              <a:buSzPct val="100000"/>
+              <a:buChar char="•"/>
+            </a:pPr>
+            <a:r>
+              <a:rPr lang="en-US" sz="2700" i="1" dirty="0">
+                <a:solidFill>
+                  <a:srgbClr val="1E2761"/>
+                </a:solidFill>
+                <a:latin typeface="Calibri" pitchFamily="34" charset="0"/>
+                <a:ea typeface="Calibri" pitchFamily="34" charset="-122"/>
+                <a:cs typeface="Calibri" pitchFamily="34" charset="-120"/>
+              </a:rPr>
+              <a:t>Seine Bitte sichert er ab, indem er …</a:t>
+            </a:r>
+            <a:endParaRPr lang="en-US" sz="2700" dirty="0"/>
+          </a:p>
+        </p:txBody>
+      </p:sp>
+      <p:sp>
+        <p:nvSpPr>
+          <p:cNvPr id="11" name="Text 9"/>
+          <p:cNvSpPr txBox="1"/>
+          <p:nvPr/>
+        </p:nvSpPr>
+        <p:spPr>
+          <a:xfrm>
+            <a:off x="457200" y="6172200"/>
+            <a:ext cx="11247120" cy="502920"/>
+          </a:xfrm>
+          <a:prstGeom prst="rect">
+            <a:avLst/>
+          </a:prstGeom>
+          <a:noFill/>
+          <a:ln/>
+        </p:spPr>
+        <p:txBody>
+          <a:bodyPr wrap="square" lIns="0" tIns="0" rIns="0" bIns="0" rtlCol="0" anchor="t"/>
+          <a:lstStyle/>
+          <a:p>
             <a:pPr indent="0" marL="0">
-              <a:spcAft>
-                <a:spcPts val="1000"/>
-              </a:spcAft>
-              <a:buNone/>
-            </a:pPr>
-            <a:r>
-              <a:rPr lang="en-US" sz="2700" dirty="0">
-                <a:solidFill>
-                  <a:srgbClr val="CADCFC"/>
-                </a:solidFill>
-                <a:latin typeface="Calibri" pitchFamily="34" charset="0"/>
-                <a:ea typeface="Calibri" pitchFamily="34" charset="-122"/>
-                <a:cs typeface="Calibri" pitchFamily="34" charset="-120"/>
-              </a:rPr>
-              <a:t>Warum appelliert er so vorsichtig und versteckt?</a:t>
-            </a:r>
-            <a:endParaRPr lang="en-US" sz="2700" dirty="0"/>
-          </a:p>
-          <a:p>
-            <a:pPr indent="0" marL="0">
-              <a:spcAft>
-                <a:spcPts val="1000"/>
-              </a:spcAft>
-              <a:buNone/>
-            </a:pPr>
-            <a:r>
-              <a:rPr lang="en-US" sz="2700" dirty="0">
-                <a:solidFill>
-                  <a:srgbClr val="CADCFC"/>
-                </a:solidFill>
-                <a:latin typeface="Calibri" pitchFamily="34" charset="0"/>
-                <a:ea typeface="Calibri" pitchFamily="34" charset="-122"/>
-                <a:cs typeface="Calibri" pitchFamily="34" charset="-120"/>
-              </a:rPr>
-              <a:t>Angenommen, der Vater hätte den Brief gelesen: Hätte er verstanden, worum Kafka ihn bittet?</a:t>
+              <a:buNone/>
+            </a:pPr>
+            <a:r>
+              <a:rPr lang="en-US" sz="2700" i="1" dirty="0">
+                <a:solidFill>
+                  <a:srgbClr val="5B6B8C"/>
+                </a:solidFill>
+                <a:latin typeface="Calibri" pitchFamily="34" charset="0"/>
+                <a:ea typeface="Calibri" pitchFamily="34" charset="-122"/>
+                <a:cs typeface="Calibri" pitchFamily="34" charset="-120"/>
+              </a:rPr>
+              <a:t>Allein, direkt auf dem Arbeitsblatt.</a:t>
             </a:r>
             <a:endParaRPr lang="en-US" sz="2700" dirty="0"/>
           </a:p>
@@ -3443,6 +3796,736 @@
                 <a:ea typeface="Cambria" pitchFamily="34" charset="-122"/>
                 <a:cs typeface="Cambria" pitchFamily="34" charset="-120"/>
               </a:rPr>
+              <a:t>Aufgabe 3: Visualisierung</a:t>
+            </a:r>
+            <a:endParaRPr lang="en-US" sz="3000" dirty="0"/>
+          </a:p>
+        </p:txBody>
+      </p:sp>
+      <p:sp>
+        <p:nvSpPr>
+          <p:cNvPr id="4" name="Shape 2"/>
+          <p:cNvSpPr/>
+          <p:nvPr/>
+        </p:nvSpPr>
+        <p:spPr>
+          <a:xfrm>
+            <a:off x="9966960" y="137160"/>
+            <a:ext cx="1920240" cy="640080"/>
+          </a:xfrm>
+          <a:prstGeom prst="roundRect">
+            <a:avLst>
+              <a:gd name="adj" fmla="val 17143"/>
+            </a:avLst>
+          </a:prstGeom>
+          <a:solidFill>
+            <a:srgbClr val="D9534F"/>
+          </a:solidFill>
+          <a:ln/>
+        </p:spPr>
+      </p:sp>
+      <p:sp>
+        <p:nvSpPr>
+          <p:cNvPr id="5" name="Text 3"/>
+          <p:cNvSpPr txBox="1"/>
+          <p:nvPr/>
+        </p:nvSpPr>
+        <p:spPr>
+          <a:xfrm>
+            <a:off x="9966960" y="137160"/>
+            <a:ext cx="1920240" cy="640080"/>
+          </a:xfrm>
+          <a:prstGeom prst="rect">
+            <a:avLst/>
+          </a:prstGeom>
+          <a:noFill/>
+          <a:ln/>
+        </p:spPr>
+        <p:txBody>
+          <a:bodyPr wrap="square" lIns="0" tIns="0" rIns="0" bIns="0" rtlCol="0" anchor="ctr"/>
+          <a:lstStyle/>
+          <a:p>
+            <a:pPr algn="ctr" indent="0" marL="0">
+              <a:buNone/>
+            </a:pPr>
+            <a:r>
+              <a:rPr lang="en-US" sz="2700" b="1" dirty="0">
+                <a:solidFill>
+                  <a:srgbClr val="FFFFFF"/>
+                </a:solidFill>
+                <a:latin typeface="Calibri" pitchFamily="34" charset="0"/>
+                <a:ea typeface="Calibri" pitchFamily="34" charset="-122"/>
+                <a:cs typeface="Calibri" pitchFamily="34" charset="-120"/>
+              </a:rPr>
+              <a:t>6 Min.</a:t>
+            </a:r>
+            <a:endParaRPr lang="en-US" sz="2700" dirty="0"/>
+          </a:p>
+        </p:txBody>
+      </p:sp>
+      <p:sp>
+        <p:nvSpPr>
+          <p:cNvPr id="6" name="Shape 4"/>
+          <p:cNvSpPr/>
+          <p:nvPr/>
+        </p:nvSpPr>
+        <p:spPr>
+          <a:xfrm>
+            <a:off x="457200" y="1143000"/>
+            <a:ext cx="11247120" cy="1188720"/>
+          </a:xfrm>
+          <a:prstGeom prst="roundRect">
+            <a:avLst>
+              <a:gd name="adj" fmla="val 6154"/>
+            </a:avLst>
+          </a:prstGeom>
+          <a:solidFill>
+            <a:srgbClr val="F4F7FD"/>
+          </a:solidFill>
+          <a:ln/>
+        </p:spPr>
+      </p:sp>
+      <p:sp>
+        <p:nvSpPr>
+          <p:cNvPr id="7" name="Text 5"/>
+          <p:cNvSpPr txBox="1"/>
+          <p:nvPr/>
+        </p:nvSpPr>
+        <p:spPr>
+          <a:xfrm>
+            <a:off x="731520" y="1143000"/>
+            <a:ext cx="10789920" cy="1188720"/>
+          </a:xfrm>
+          <a:prstGeom prst="rect">
+            <a:avLst/>
+          </a:prstGeom>
+          <a:noFill/>
+          <a:ln/>
+        </p:spPr>
+        <p:txBody>
+          <a:bodyPr wrap="square" lIns="0" tIns="0" rIns="0" bIns="0" rtlCol="0" anchor="ctr"/>
+          <a:lstStyle/>
+          <a:p>
+            <a:pPr indent="0" marL="0">
+              <a:buNone/>
+            </a:pPr>
+            <a:r>
+              <a:rPr lang="en-US" sz="2700" b="1" dirty="0">
+                <a:solidFill>
+                  <a:srgbClr val="1E2761"/>
+                </a:solidFill>
+                <a:latin typeface="Calibri" pitchFamily="34" charset="0"/>
+                <a:ea typeface="Calibri" pitchFamily="34" charset="-122"/>
+                <a:cs typeface="Calibri" pitchFamily="34" charset="-120"/>
+              </a:rPr>
+              <a:t>Trage deine Ergebnisse in das Kommunikationsquadrat ein – vor allem in den Quadranten Appell.</a:t>
+            </a:r>
+            <a:endParaRPr lang="en-US" sz="2700" dirty="0"/>
+          </a:p>
+        </p:txBody>
+      </p:sp>
+      <p:sp>
+        <p:nvSpPr>
+          <p:cNvPr id="8" name="Shape 6"/>
+          <p:cNvSpPr/>
+          <p:nvPr/>
+        </p:nvSpPr>
+        <p:spPr>
+          <a:xfrm>
+            <a:off x="2194560" y="2606040"/>
+            <a:ext cx="3794760" cy="1600200"/>
+          </a:xfrm>
+          <a:prstGeom prst="roundRect">
+            <a:avLst>
+              <a:gd name="adj" fmla="val 2286"/>
+            </a:avLst>
+          </a:prstGeom>
+          <a:solidFill>
+            <a:srgbClr val="F4F7FD"/>
+          </a:solidFill>
+          <a:ln w="9525">
+            <a:solidFill>
+              <a:srgbClr val="D5DCEC"/>
+            </a:solidFill>
+            <a:prstDash val="solid"/>
+          </a:ln>
+        </p:spPr>
+      </p:sp>
+      <p:sp>
+        <p:nvSpPr>
+          <p:cNvPr id="9" name="Text 7"/>
+          <p:cNvSpPr txBox="1"/>
+          <p:nvPr/>
+        </p:nvSpPr>
+        <p:spPr>
+          <a:xfrm>
+            <a:off x="2194560" y="2606040"/>
+            <a:ext cx="3794760" cy="1600200"/>
+          </a:xfrm>
+          <a:prstGeom prst="rect">
+            <a:avLst/>
+          </a:prstGeom>
+          <a:noFill/>
+          <a:ln/>
+        </p:spPr>
+        <p:txBody>
+          <a:bodyPr wrap="square" lIns="0" tIns="0" rIns="0" bIns="0" rtlCol="0" anchor="ctr"/>
+          <a:lstStyle/>
+          <a:p>
+            <a:pPr algn="ctr" indent="0" marL="0">
+              <a:buNone/>
+            </a:pPr>
+            <a:r>
+              <a:rPr lang="en-US" sz="2700" b="1" dirty="0">
+                <a:solidFill>
+                  <a:srgbClr val="1E2761"/>
+                </a:solidFill>
+                <a:latin typeface="Calibri" pitchFamily="34" charset="0"/>
+                <a:ea typeface="Calibri" pitchFamily="34" charset="-122"/>
+                <a:cs typeface="Calibri" pitchFamily="34" charset="-120"/>
+              </a:rPr>
+              <a:t>Sachinhalt</a:t>
+            </a:r>
+            <a:endParaRPr lang="en-US" sz="2700" dirty="0"/>
+          </a:p>
+        </p:txBody>
+      </p:sp>
+      <p:sp>
+        <p:nvSpPr>
+          <p:cNvPr id="10" name="Shape 8"/>
+          <p:cNvSpPr/>
+          <p:nvPr/>
+        </p:nvSpPr>
+        <p:spPr>
+          <a:xfrm>
+            <a:off x="6126480" y="2606040"/>
+            <a:ext cx="3794760" cy="1600200"/>
+          </a:xfrm>
+          <a:prstGeom prst="roundRect">
+            <a:avLst>
+              <a:gd name="adj" fmla="val 2286"/>
+            </a:avLst>
+          </a:prstGeom>
+          <a:solidFill>
+            <a:srgbClr val="F4F7FD"/>
+          </a:solidFill>
+          <a:ln w="9525">
+            <a:solidFill>
+              <a:srgbClr val="D5DCEC"/>
+            </a:solidFill>
+            <a:prstDash val="solid"/>
+          </a:ln>
+        </p:spPr>
+      </p:sp>
+      <p:sp>
+        <p:nvSpPr>
+          <p:cNvPr id="11" name="Text 9"/>
+          <p:cNvSpPr txBox="1"/>
+          <p:nvPr/>
+        </p:nvSpPr>
+        <p:spPr>
+          <a:xfrm>
+            <a:off x="6126480" y="2606040"/>
+            <a:ext cx="3794760" cy="1600200"/>
+          </a:xfrm>
+          <a:prstGeom prst="rect">
+            <a:avLst/>
+          </a:prstGeom>
+          <a:noFill/>
+          <a:ln/>
+        </p:spPr>
+        <p:txBody>
+          <a:bodyPr wrap="square" lIns="0" tIns="0" rIns="0" bIns="0" rtlCol="0" anchor="ctr"/>
+          <a:lstStyle/>
+          <a:p>
+            <a:pPr algn="ctr" indent="0" marL="0">
+              <a:buNone/>
+            </a:pPr>
+            <a:r>
+              <a:rPr lang="en-US" sz="2700" b="1" dirty="0">
+                <a:solidFill>
+                  <a:srgbClr val="1E2761"/>
+                </a:solidFill>
+                <a:latin typeface="Calibri" pitchFamily="34" charset="0"/>
+                <a:ea typeface="Calibri" pitchFamily="34" charset="-122"/>
+                <a:cs typeface="Calibri" pitchFamily="34" charset="-120"/>
+              </a:rPr>
+              <a:t>Selbstkundgabe</a:t>
+            </a:r>
+            <a:endParaRPr lang="en-US" sz="2700" dirty="0"/>
+          </a:p>
+        </p:txBody>
+      </p:sp>
+      <p:sp>
+        <p:nvSpPr>
+          <p:cNvPr id="12" name="Shape 10"/>
+          <p:cNvSpPr/>
+          <p:nvPr/>
+        </p:nvSpPr>
+        <p:spPr>
+          <a:xfrm>
+            <a:off x="2194560" y="4343400"/>
+            <a:ext cx="3794760" cy="1600200"/>
+          </a:xfrm>
+          <a:prstGeom prst="roundRect">
+            <a:avLst>
+              <a:gd name="adj" fmla="val 2286"/>
+            </a:avLst>
+          </a:prstGeom>
+          <a:solidFill>
+            <a:srgbClr val="F4F7FD"/>
+          </a:solidFill>
+          <a:ln w="9525">
+            <a:solidFill>
+              <a:srgbClr val="D5DCEC"/>
+            </a:solidFill>
+            <a:prstDash val="solid"/>
+          </a:ln>
+        </p:spPr>
+      </p:sp>
+      <p:sp>
+        <p:nvSpPr>
+          <p:cNvPr id="13" name="Text 11"/>
+          <p:cNvSpPr txBox="1"/>
+          <p:nvPr/>
+        </p:nvSpPr>
+        <p:spPr>
+          <a:xfrm>
+            <a:off x="2194560" y="4343400"/>
+            <a:ext cx="3794760" cy="1600200"/>
+          </a:xfrm>
+          <a:prstGeom prst="rect">
+            <a:avLst/>
+          </a:prstGeom>
+          <a:noFill/>
+          <a:ln/>
+        </p:spPr>
+        <p:txBody>
+          <a:bodyPr wrap="square" lIns="0" tIns="0" rIns="0" bIns="0" rtlCol="0" anchor="ctr"/>
+          <a:lstStyle/>
+          <a:p>
+            <a:pPr algn="ctr" indent="0" marL="0">
+              <a:buNone/>
+            </a:pPr>
+            <a:r>
+              <a:rPr lang="en-US" sz="2700" b="1" dirty="0">
+                <a:solidFill>
+                  <a:srgbClr val="1E2761"/>
+                </a:solidFill>
+                <a:latin typeface="Calibri" pitchFamily="34" charset="0"/>
+                <a:ea typeface="Calibri" pitchFamily="34" charset="-122"/>
+                <a:cs typeface="Calibri" pitchFamily="34" charset="-120"/>
+              </a:rPr>
+              <a:t>Beziehung</a:t>
+            </a:r>
+            <a:endParaRPr lang="en-US" sz="2700" dirty="0"/>
+          </a:p>
+        </p:txBody>
+      </p:sp>
+      <p:sp>
+        <p:nvSpPr>
+          <p:cNvPr id="14" name="Shape 12"/>
+          <p:cNvSpPr/>
+          <p:nvPr/>
+        </p:nvSpPr>
+        <p:spPr>
+          <a:xfrm>
+            <a:off x="6126480" y="4343400"/>
+            <a:ext cx="3794760" cy="1600200"/>
+          </a:xfrm>
+          <a:prstGeom prst="roundRect">
+            <a:avLst>
+              <a:gd name="adj" fmla="val 2286"/>
+            </a:avLst>
+          </a:prstGeom>
+          <a:solidFill>
+            <a:srgbClr val="FDECEA"/>
+          </a:solidFill>
+          <a:ln w="31750">
+            <a:solidFill>
+              <a:srgbClr val="D9534F"/>
+            </a:solidFill>
+            <a:prstDash val="solid"/>
+          </a:ln>
+        </p:spPr>
+      </p:sp>
+      <p:sp>
+        <p:nvSpPr>
+          <p:cNvPr id="15" name="Text 13"/>
+          <p:cNvSpPr txBox="1"/>
+          <p:nvPr/>
+        </p:nvSpPr>
+        <p:spPr>
+          <a:xfrm>
+            <a:off x="6126480" y="4343400"/>
+            <a:ext cx="3794760" cy="1600200"/>
+          </a:xfrm>
+          <a:prstGeom prst="rect">
+            <a:avLst/>
+          </a:prstGeom>
+          <a:noFill/>
+          <a:ln/>
+        </p:spPr>
+        <p:txBody>
+          <a:bodyPr wrap="square" lIns="0" tIns="0" rIns="0" bIns="0" rtlCol="0" anchor="ctr"/>
+          <a:lstStyle/>
+          <a:p>
+            <a:pPr algn="ctr" indent="0" marL="0">
+              <a:buNone/>
+            </a:pPr>
+            <a:r>
+              <a:rPr lang="en-US" sz="2700" b="1" dirty="0">
+                <a:solidFill>
+                  <a:srgbClr val="D9534F"/>
+                </a:solidFill>
+                <a:latin typeface="Calibri" pitchFamily="34" charset="0"/>
+                <a:ea typeface="Calibri" pitchFamily="34" charset="-122"/>
+                <a:cs typeface="Calibri" pitchFamily="34" charset="-120"/>
+              </a:rPr>
+              <a:t>Appell</a:t>
+            </a:r>
+            <a:endParaRPr lang="en-US" sz="2700" dirty="0"/>
+          </a:p>
+        </p:txBody>
+      </p:sp>
+      <p:sp>
+        <p:nvSpPr>
+          <p:cNvPr id="16" name="Text 14"/>
+          <p:cNvSpPr txBox="1"/>
+          <p:nvPr/>
+        </p:nvSpPr>
+        <p:spPr>
+          <a:xfrm>
+            <a:off x="457200" y="6172200"/>
+            <a:ext cx="11247120" cy="502920"/>
+          </a:xfrm>
+          <a:prstGeom prst="rect">
+            <a:avLst/>
+          </a:prstGeom>
+          <a:noFill/>
+          <a:ln/>
+        </p:spPr>
+        <p:txBody>
+          <a:bodyPr wrap="square" lIns="0" tIns="0" rIns="0" bIns="0" rtlCol="0" anchor="t"/>
+          <a:lstStyle/>
+          <a:p>
+            <a:pPr indent="0" marL="0">
+              <a:buNone/>
+            </a:pPr>
+            <a:r>
+              <a:rPr lang="en-US" sz="2700" i="1" dirty="0">
+                <a:solidFill>
+                  <a:srgbClr val="5B6B8C"/>
+                </a:solidFill>
+                <a:latin typeface="Calibri" pitchFamily="34" charset="0"/>
+                <a:ea typeface="Calibri" pitchFamily="34" charset="-122"/>
+                <a:cs typeface="Calibri" pitchFamily="34" charset="-120"/>
+              </a:rPr>
+              <a:t>Allein, direkt auf dem Arbeitsblatt.</a:t>
+            </a:r>
+            <a:endParaRPr lang="en-US" sz="2700" dirty="0"/>
+          </a:p>
+        </p:txBody>
+      </p:sp>
+    </p:spTree>
+  </p:cSld>
+  <p:clrMapOvr>
+    <a:masterClrMapping/>
+  </p:clrMapOvr>
+</p:sld>
+</file>
+
+<file path=ppt/slides/slide15.xml><?xml version="1.0" encoding="utf-8"?>
+<p:sld xmlns:a="http://schemas.openxmlformats.org/drawingml/2006/main" xmlns:r="http://schemas.openxmlformats.org/officeDocument/2006/relationships" xmlns:p="http://schemas.openxmlformats.org/presentationml/2006/main">
+  <p:cSld name="Slide 15">
+    <p:bg>
+      <p:bgPr>
+        <a:solidFill>
+          <a:srgbClr val="1E2761"/>
+        </a:solidFill>
+      </p:bgPr>
+    </p:bg>
+    <p:spTree>
+      <p:nvGrpSpPr>
+        <p:cNvPr id="1" name=""/>
+        <p:cNvGrpSpPr/>
+        <p:nvPr/>
+      </p:nvGrpSpPr>
+      <p:grpSpPr>
+        <a:xfrm>
+          <a:off x="0" y="0"/>
+          <a:ext cx="0" cy="0"/>
+          <a:chOff x="0" y="0"/>
+          <a:chExt cx="0" cy="0"/>
+        </a:xfrm>
+      </p:grpSpPr>
+      <p:sp>
+        <p:nvSpPr>
+          <p:cNvPr id="2" name="Shape 0"/>
+          <p:cNvSpPr/>
+          <p:nvPr/>
+        </p:nvSpPr>
+        <p:spPr>
+          <a:xfrm>
+            <a:off x="9692640" y="-1463040"/>
+            <a:ext cx="4206240" cy="4206240"/>
+          </a:xfrm>
+          <a:prstGeom prst="ellipse">
+            <a:avLst/>
+          </a:prstGeom>
+          <a:solidFill>
+            <a:srgbClr val="24306E"/>
+          </a:solidFill>
+          <a:ln/>
+        </p:spPr>
+      </p:sp>
+      <p:sp>
+        <p:nvSpPr>
+          <p:cNvPr id="3" name="Shape 1"/>
+          <p:cNvSpPr/>
+          <p:nvPr/>
+        </p:nvSpPr>
+        <p:spPr>
+          <a:xfrm>
+            <a:off x="822960" y="1280160"/>
+            <a:ext cx="2926080" cy="548640"/>
+          </a:xfrm>
+          <a:prstGeom prst="roundRect">
+            <a:avLst>
+              <a:gd name="adj" fmla="val 50000"/>
+            </a:avLst>
+          </a:prstGeom>
+          <a:solidFill>
+            <a:srgbClr val="D9534F"/>
+          </a:solidFill>
+          <a:ln/>
+        </p:spPr>
+      </p:sp>
+      <p:sp>
+        <p:nvSpPr>
+          <p:cNvPr id="4" name="Text 2"/>
+          <p:cNvSpPr txBox="1"/>
+          <p:nvPr/>
+        </p:nvSpPr>
+        <p:spPr>
+          <a:xfrm>
+            <a:off x="822960" y="1280160"/>
+            <a:ext cx="2926080" cy="548640"/>
+          </a:xfrm>
+          <a:prstGeom prst="rect">
+            <a:avLst/>
+          </a:prstGeom>
+          <a:noFill/>
+          <a:ln/>
+        </p:spPr>
+        <p:txBody>
+          <a:bodyPr wrap="square" lIns="0" tIns="0" rIns="0" bIns="0" rtlCol="0" anchor="ctr"/>
+          <a:lstStyle/>
+          <a:p>
+            <a:pPr algn="ctr" indent="0" marL="0">
+              <a:buNone/>
+            </a:pPr>
+            <a:r>
+              <a:rPr lang="en-US" sz="2700" b="1" dirty="0">
+                <a:solidFill>
+                  <a:srgbClr val="FFFFFF"/>
+                </a:solidFill>
+                <a:latin typeface="Calibri" pitchFamily="34" charset="0"/>
+                <a:ea typeface="Calibri" pitchFamily="34" charset="-122"/>
+                <a:cs typeface="Calibri" pitchFamily="34" charset="-120"/>
+              </a:rPr>
+              <a:t>REFLEXION</a:t>
+            </a:r>
+            <a:endParaRPr lang="en-US" sz="2700" dirty="0"/>
+          </a:p>
+        </p:txBody>
+      </p:sp>
+      <p:sp>
+        <p:nvSpPr>
+          <p:cNvPr id="5" name="Text 3"/>
+          <p:cNvSpPr txBox="1"/>
+          <p:nvPr/>
+        </p:nvSpPr>
+        <p:spPr>
+          <a:xfrm>
+            <a:off x="822960" y="2194560"/>
+            <a:ext cx="10424160" cy="822960"/>
+          </a:xfrm>
+          <a:prstGeom prst="rect">
+            <a:avLst/>
+          </a:prstGeom>
+          <a:noFill/>
+          <a:ln/>
+        </p:spPr>
+        <p:txBody>
+          <a:bodyPr wrap="square" lIns="0" tIns="0" rIns="0" bIns="0" rtlCol="0" anchor="t"/>
+          <a:lstStyle/>
+          <a:p>
+            <a:pPr indent="0" marL="0">
+              <a:buNone/>
+            </a:pPr>
+            <a:r>
+              <a:rPr lang="en-US" sz="3200" b="1" dirty="0">
+                <a:solidFill>
+                  <a:srgbClr val="FFFFFF"/>
+                </a:solidFill>
+                <a:latin typeface="Cambria" pitchFamily="34" charset="0"/>
+                <a:ea typeface="Cambria" pitchFamily="34" charset="-122"/>
+                <a:cs typeface="Cambria" pitchFamily="34" charset="-120"/>
+              </a:rPr>
+              <a:t>Kafka hat den Brief nie übergeben.</a:t>
+            </a:r>
+            <a:endParaRPr lang="en-US" sz="3200" dirty="0"/>
+          </a:p>
+        </p:txBody>
+      </p:sp>
+      <p:sp>
+        <p:nvSpPr>
+          <p:cNvPr id="6" name="Text 4"/>
+          <p:cNvSpPr txBox="1"/>
+          <p:nvPr/>
+        </p:nvSpPr>
+        <p:spPr>
+          <a:xfrm>
+            <a:off x="822960" y="3291840"/>
+            <a:ext cx="10424160" cy="2377440"/>
+          </a:xfrm>
+          <a:prstGeom prst="rect">
+            <a:avLst/>
+          </a:prstGeom>
+          <a:noFill/>
+          <a:ln/>
+        </p:spPr>
+        <p:txBody>
+          <a:bodyPr wrap="square" lIns="0" tIns="0" rIns="0" bIns="0" rtlCol="0" anchor="t"/>
+          <a:lstStyle/>
+          <a:p>
+            <a:pPr indent="0" marL="0">
+              <a:spcAft>
+                <a:spcPts val="1000"/>
+              </a:spcAft>
+              <a:buNone/>
+            </a:pPr>
+            <a:r>
+              <a:rPr lang="en-US" sz="2700" dirty="0">
+                <a:solidFill>
+                  <a:srgbClr val="CADCFC"/>
+                </a:solidFill>
+                <a:latin typeface="Calibri" pitchFamily="34" charset="0"/>
+                <a:ea typeface="Calibri" pitchFamily="34" charset="-122"/>
+                <a:cs typeface="Calibri" pitchFamily="34" charset="-120"/>
+              </a:rPr>
+              <a:t>Warum appelliert er so vorsichtig und versteckt?</a:t>
+            </a:r>
+            <a:endParaRPr lang="en-US" sz="2700" dirty="0"/>
+          </a:p>
+          <a:p>
+            <a:pPr indent="0" marL="0">
+              <a:spcAft>
+                <a:spcPts val="1000"/>
+              </a:spcAft>
+              <a:buNone/>
+            </a:pPr>
+            <a:r>
+              <a:rPr lang="en-US" sz="2700" dirty="0">
+                <a:solidFill>
+                  <a:srgbClr val="CADCFC"/>
+                </a:solidFill>
+                <a:latin typeface="Calibri" pitchFamily="34" charset="0"/>
+                <a:ea typeface="Calibri" pitchFamily="34" charset="-122"/>
+                <a:cs typeface="Calibri" pitchFamily="34" charset="-120"/>
+              </a:rPr>
+              <a:t>Angenommen, der Vater hätte den Brief gelesen: Hätte er verstanden, worum Kafka ihn bittet?</a:t>
+            </a:r>
+            <a:endParaRPr lang="en-US" sz="2700" dirty="0"/>
+          </a:p>
+        </p:txBody>
+      </p:sp>
+    </p:spTree>
+  </p:cSld>
+  <p:clrMapOvr>
+    <a:masterClrMapping/>
+  </p:clrMapOvr>
+</p:sld>
+</file>
+
+<file path=ppt/slides/slide16.xml><?xml version="1.0" encoding="utf-8"?>
+<p:sld xmlns:a="http://schemas.openxmlformats.org/drawingml/2006/main" xmlns:r="http://schemas.openxmlformats.org/officeDocument/2006/relationships" xmlns:p="http://schemas.openxmlformats.org/presentationml/2006/main">
+  <p:cSld name="Slide 16">
+    <p:bg>
+      <p:bgPr>
+        <a:solidFill>
+          <a:srgbClr val="FFFFFF"/>
+        </a:solidFill>
+      </p:bgPr>
+    </p:bg>
+    <p:spTree>
+      <p:nvGrpSpPr>
+        <p:cNvPr id="1" name=""/>
+        <p:cNvGrpSpPr/>
+        <p:nvPr/>
+      </p:nvGrpSpPr>
+      <p:grpSpPr>
+        <a:xfrm>
+          <a:off x="0" y="0"/>
+          <a:ext cx="0" cy="0"/>
+          <a:chOff x="0" y="0"/>
+          <a:chExt cx="0" cy="0"/>
+        </a:xfrm>
+      </p:grpSpPr>
+      <p:sp>
+        <p:nvSpPr>
+          <p:cNvPr id="2" name="Shape 0"/>
+          <p:cNvSpPr/>
+          <p:nvPr/>
+        </p:nvSpPr>
+        <p:spPr>
+          <a:xfrm>
+            <a:off x="0" y="0"/>
+            <a:ext cx="12191695" cy="914400"/>
+          </a:xfrm>
+          <a:prstGeom prst="roundRect">
+            <a:avLst/>
+          </a:prstGeom>
+          <a:solidFill>
+            <a:srgbClr val="1E2761"/>
+          </a:solidFill>
+          <a:ln/>
+        </p:spPr>
+      </p:sp>
+      <p:sp>
+        <p:nvSpPr>
+          <p:cNvPr id="3" name="Text 1"/>
+          <p:cNvSpPr txBox="1"/>
+          <p:nvPr/>
+        </p:nvSpPr>
+        <p:spPr>
+          <a:xfrm>
+            <a:off x="457200" y="0"/>
+            <a:ext cx="9326880" cy="914400"/>
+          </a:xfrm>
+          <a:prstGeom prst="rect">
+            <a:avLst/>
+          </a:prstGeom>
+          <a:noFill/>
+          <a:ln/>
+        </p:spPr>
+        <p:txBody>
+          <a:bodyPr wrap="square" lIns="0" tIns="0" rIns="0" bIns="0" rtlCol="0" anchor="ctr"/>
+          <a:lstStyle/>
+          <a:p>
+            <a:pPr indent="0" marL="0">
+              <a:buNone/>
+            </a:pPr>
+            <a:r>
+              <a:rPr lang="en-US" sz="3000" b="1" dirty="0">
+                <a:solidFill>
+                  <a:srgbClr val="FFFFFF"/>
+                </a:solidFill>
+                <a:latin typeface="Cambria" pitchFamily="34" charset="0"/>
+                <a:ea typeface="Cambria" pitchFamily="34" charset="-122"/>
+                <a:cs typeface="Cambria" pitchFamily="34" charset="-120"/>
+              </a:rPr>
               <a:t>Transfer: Kafkas Rede an den Vater</a:t>
             </a:r>
             <a:endParaRPr lang="en-US" sz="3000" dirty="0"/>
@@ -5053,7 +6136,7 @@
                 <a:ea typeface="Calibri" pitchFamily="34" charset="-122"/>
                 <a:cs typeface="Calibri" pitchFamily="34" charset="-120"/>
               </a:rPr>
-              <a:t>Training folgt in den nächsten Stunden – achtet schon heute beim Schreiben darauf.</a:t>
+              <a:t>Achtet schon heute beim Schreiben auf diese Fehlerquellen!</a:t>
             </a:r>
             <a:endParaRPr lang="en-US" sz="2700" dirty="0"/>
           </a:p>
@@ -5709,7 +6792,7 @@
                 <a:ea typeface="Calibri" pitchFamily="34" charset="-122"/>
                 <a:cs typeface="Calibri" pitchFamily="34" charset="-120"/>
               </a:rPr>
-              <a:t>verbal · paraverbal · nonverbal</a:t>
+              <a:t>3 Ebenen</a:t>
             </a:r>
             <a:endParaRPr lang="en-US" sz="2700" dirty="0"/>
           </a:p>
@@ -5966,7 +7049,7 @@
                 <a:ea typeface="Cambria" pitchFamily="34" charset="-122"/>
                 <a:cs typeface="Cambria" pitchFamily="34" charset="-120"/>
               </a:rPr>
-              <a:t>Kafka und sein Vater</a:t>
+              <a:t>Kontextualisieren</a:t>
             </a:r>
             <a:endParaRPr lang="en-US" sz="3000" dirty="0"/>
           </a:p>
@@ -5974,157 +7057,36 @@
       </p:sp>
       <p:sp>
         <p:nvSpPr>
-          <p:cNvPr id="4" name="Text 2"/>
-          <p:cNvSpPr txBox="1"/>
-          <p:nvPr/>
-        </p:nvSpPr>
-        <p:spPr>
-          <a:xfrm>
-            <a:off x="8503920" y="137160"/>
-            <a:ext cx="3383280" cy="640080"/>
-          </a:xfrm>
-          <a:prstGeom prst="rect">
-            <a:avLst/>
-          </a:prstGeom>
-          <a:noFill/>
-          <a:ln/>
-        </p:spPr>
-        <p:txBody>
-          <a:bodyPr wrap="square" lIns="0" tIns="0" rIns="0" bIns="0" rtlCol="0" anchor="ctr"/>
-          <a:lstStyle/>
-          <a:p>
-            <a:pPr algn="r" indent="0" marL="0">
-              <a:buNone/>
-            </a:pPr>
-            <a:r>
-              <a:rPr lang="en-US" sz="2700" b="1" dirty="0">
-                <a:solidFill>
-                  <a:srgbClr val="CADCFC"/>
-                </a:solidFill>
-                <a:latin typeface="Calibri" pitchFamily="34" charset="0"/>
-                <a:ea typeface="Calibri" pitchFamily="34" charset="-122"/>
-                <a:cs typeface="Calibri" pitchFamily="34" charset="-120"/>
-              </a:rPr>
-              <a:t>VORWISSEN</a:t>
-            </a:r>
-            <a:endParaRPr lang="en-US" sz="2700" dirty="0"/>
-          </a:p>
-        </p:txBody>
-      </p:sp>
-      <p:sp>
-        <p:nvSpPr>
-          <p:cNvPr id="5" name="Text 3"/>
-          <p:cNvSpPr txBox="1"/>
-          <p:nvPr/>
-        </p:nvSpPr>
-        <p:spPr>
-          <a:xfrm>
-            <a:off x="731520" y="1280160"/>
-            <a:ext cx="10789920" cy="3291840"/>
-          </a:xfrm>
-          <a:prstGeom prst="rect">
-            <a:avLst/>
-          </a:prstGeom>
-          <a:noFill/>
-          <a:ln/>
-        </p:spPr>
-        <p:txBody>
-          <a:bodyPr wrap="square" lIns="0" tIns="0" rIns="0" bIns="0" rtlCol="0" anchor="t"/>
-          <a:lstStyle/>
-          <a:p>
-            <a:pPr marL="304800" indent="-304800">
-              <a:spcAft>
-                <a:spcPts val="1600"/>
-              </a:spcAft>
-              <a:buSzPct val="100000"/>
-              <a:buChar char="•"/>
-            </a:pPr>
-            <a:r>
-              <a:rPr lang="en-US" sz="2700" dirty="0">
-                <a:solidFill>
-                  <a:srgbClr val="1E2761"/>
-                </a:solidFill>
-                <a:latin typeface="Calibri" pitchFamily="34" charset="0"/>
-                <a:ea typeface="Calibri" pitchFamily="34" charset="-122"/>
-                <a:cs typeface="Calibri" pitchFamily="34" charset="-120"/>
-              </a:rPr>
-              <a:t>Die Beziehung ist gestört – der Sohn hat Furcht, der Vater versteht ihn nicht.</a:t>
-            </a:r>
-            <a:endParaRPr lang="en-US" sz="2700" dirty="0"/>
-          </a:p>
-          <a:p>
-            <a:pPr marL="304800" indent="-304800">
-              <a:spcAft>
-                <a:spcPts val="1600"/>
-              </a:spcAft>
-              <a:buSzPct val="100000"/>
-              <a:buChar char="•"/>
-            </a:pPr>
-            <a:r>
-              <a:rPr lang="en-US" sz="2700" dirty="0">
-                <a:solidFill>
-                  <a:srgbClr val="1E2761"/>
-                </a:solidFill>
-                <a:latin typeface="Calibri" pitchFamily="34" charset="0"/>
-                <a:ea typeface="Calibri" pitchFamily="34" charset="-122"/>
-                <a:cs typeface="Calibri" pitchFamily="34" charset="-120"/>
-              </a:rPr>
-              <a:t>Max Brod hat deshalb an den Vater geschrieben.</a:t>
-            </a:r>
-            <a:endParaRPr lang="en-US" sz="2700" dirty="0"/>
-          </a:p>
-          <a:p>
-            <a:pPr marL="304800" indent="-304800">
-              <a:buSzPct val="100000"/>
-              <a:buChar char="•"/>
-            </a:pPr>
-            <a:r>
-              <a:rPr lang="en-US" sz="2700" b="1" dirty="0">
-                <a:solidFill>
-                  <a:srgbClr val="1E2761"/>
-                </a:solidFill>
-                <a:latin typeface="Calibri" pitchFamily="34" charset="0"/>
-                <a:ea typeface="Calibri" pitchFamily="34" charset="-122"/>
-                <a:cs typeface="Calibri" pitchFamily="34" charset="-120"/>
-              </a:rPr>
-              <a:t>Heute: Was will Kafka selbst von seinem Vater?</a:t>
-            </a:r>
-            <a:endParaRPr lang="en-US" sz="2700" dirty="0"/>
-          </a:p>
-        </p:txBody>
-      </p:sp>
-      <p:sp>
-        <p:nvSpPr>
-          <p:cNvPr id="6" name="Shape 4"/>
+          <p:cNvPr id="4" name="Shape 2"/>
           <p:cNvSpPr/>
           <p:nvPr/>
         </p:nvSpPr>
         <p:spPr>
           <a:xfrm>
-            <a:off x="457200" y="4846320"/>
-            <a:ext cx="11247120" cy="1097280"/>
+            <a:off x="9966960" y="137160"/>
+            <a:ext cx="1920240" cy="640080"/>
           </a:xfrm>
           <a:prstGeom prst="roundRect">
             <a:avLst>
-              <a:gd name="adj" fmla="val 6667"/>
+              <a:gd name="adj" fmla="val 17143"/>
             </a:avLst>
           </a:prstGeom>
           <a:solidFill>
-            <a:srgbClr val="FDECEA"/>
+            <a:srgbClr val="D9534F"/>
           </a:solidFill>
           <a:ln/>
         </p:spPr>
       </p:sp>
       <p:sp>
         <p:nvSpPr>
-          <p:cNvPr id="7" name="Text 5"/>
-          <p:cNvSpPr txBox="1"/>
-          <p:nvPr/>
-        </p:nvSpPr>
-        <p:spPr>
-          <a:xfrm>
-            <a:off x="731520" y="4846320"/>
-            <a:ext cx="10789920" cy="1097280"/>
+          <p:cNvPr id="5" name="Text 3"/>
+          <p:cNvSpPr txBox="1"/>
+          <p:nvPr/>
+        </p:nvSpPr>
+        <p:spPr>
+          <a:xfrm>
+            <a:off x="9966960" y="137160"/>
+            <a:ext cx="1920240" cy="640080"/>
           </a:xfrm>
           <a:prstGeom prst="rect">
             <a:avLst/>
@@ -6136,19 +7098,178 @@
           <a:bodyPr wrap="square" lIns="0" tIns="0" rIns="0" bIns="0" rtlCol="0" anchor="ctr"/>
           <a:lstStyle/>
           <a:p>
+            <a:pPr algn="ctr" indent="0" marL="0">
+              <a:buNone/>
+            </a:pPr>
+            <a:r>
+              <a:rPr lang="en-US" sz="2700" b="1" dirty="0">
+                <a:solidFill>
+                  <a:srgbClr val="FFFFFF"/>
+                </a:solidFill>
+                <a:latin typeface="Calibri" pitchFamily="34" charset="0"/>
+                <a:ea typeface="Calibri" pitchFamily="34" charset="-122"/>
+                <a:cs typeface="Calibri" pitchFamily="34" charset="-120"/>
+              </a:rPr>
+              <a:t>4 Min.</a:t>
+            </a:r>
+            <a:endParaRPr lang="en-US" sz="2700" dirty="0"/>
+          </a:p>
+        </p:txBody>
+      </p:sp>
+      <p:sp>
+        <p:nvSpPr>
+          <p:cNvPr id="6" name="Text 4"/>
+          <p:cNvSpPr txBox="1"/>
+          <p:nvPr/>
+        </p:nvSpPr>
+        <p:spPr>
+          <a:xfrm>
+            <a:off x="457200" y="1143000"/>
+            <a:ext cx="11247120" cy="1737360"/>
+          </a:xfrm>
+          <a:prstGeom prst="rect">
+            <a:avLst/>
+          </a:prstGeom>
+          <a:noFill/>
+          <a:ln/>
+        </p:spPr>
+        <p:txBody>
+          <a:bodyPr wrap="square" lIns="0" tIns="0" rIns="0" bIns="0" rtlCol="0" anchor="t"/>
+          <a:lstStyle/>
+          <a:p>
             <a:pPr indent="0" marL="0">
               <a:buNone/>
             </a:pPr>
             <a:r>
-              <a:rPr lang="en-US" sz="2700" b="1" dirty="0">
-                <a:solidFill>
-                  <a:srgbClr val="D9534F"/>
+              <a:rPr lang="en-US" sz="2700" dirty="0">
+                <a:solidFill>
+                  <a:srgbClr val="1E2761"/>
+                </a:solidFill>
+                <a:latin typeface="Calibri" pitchFamily="34" charset="0"/>
+                <a:ea typeface="Calibri" pitchFamily="34" charset="-122"/>
+                <a:cs typeface="Calibri" pitchFamily="34" charset="-120"/>
+              </a:rPr>
+              <a:t>Kontextualisiere den Auszug aus Franz Kafkas „Brief an den Vater“ an Hermann Kafka. Beziehe dich dabei mit deinem Vorwissen auf die Beziehung zwischen Vater und Sohn.</a:t>
+            </a:r>
+            <a:endParaRPr lang="en-US" sz="2700" dirty="0"/>
+          </a:p>
+        </p:txBody>
+      </p:sp>
+      <p:sp>
+        <p:nvSpPr>
+          <p:cNvPr id="7" name="Shape 5"/>
+          <p:cNvSpPr/>
+          <p:nvPr/>
+        </p:nvSpPr>
+        <p:spPr>
+          <a:xfrm>
+            <a:off x="457200" y="3063240"/>
+            <a:ext cx="11247120" cy="2011680"/>
+          </a:xfrm>
+          <a:prstGeom prst="roundRect">
+            <a:avLst>
+              <a:gd name="adj" fmla="val 3636"/>
+            </a:avLst>
+          </a:prstGeom>
+          <a:solidFill>
+            <a:srgbClr val="F4F7FD"/>
+          </a:solidFill>
+          <a:ln/>
+        </p:spPr>
+      </p:sp>
+      <p:sp>
+        <p:nvSpPr>
+          <p:cNvPr id="8" name="Shape 6"/>
+          <p:cNvSpPr/>
+          <p:nvPr/>
+        </p:nvSpPr>
+        <p:spPr>
+          <a:xfrm>
+            <a:off x="457200" y="3063240"/>
+            <a:ext cx="109728" cy="2011680"/>
+          </a:xfrm>
+          <a:prstGeom prst="rect">
+            <a:avLst/>
+          </a:prstGeom>
+          <a:solidFill>
+            <a:srgbClr val="D9534F"/>
+          </a:solidFill>
+          <a:ln/>
+        </p:spPr>
+      </p:sp>
+      <p:sp>
+        <p:nvSpPr>
+          <p:cNvPr id="9" name="Text 7"/>
+          <p:cNvSpPr txBox="1"/>
+          <p:nvPr/>
+        </p:nvSpPr>
+        <p:spPr>
+          <a:xfrm>
+            <a:off x="822960" y="3063240"/>
+            <a:ext cx="10698480" cy="2011680"/>
+          </a:xfrm>
+          <a:prstGeom prst="rect">
+            <a:avLst/>
+          </a:prstGeom>
+          <a:noFill/>
+          <a:ln/>
+        </p:spPr>
+        <p:txBody>
+          <a:bodyPr wrap="square" lIns="0" tIns="0" rIns="0" bIns="0" rtlCol="0" anchor="ctr"/>
+          <a:lstStyle/>
+          <a:p>
+            <a:pPr indent="0" marL="0">
+              <a:buNone/>
+            </a:pPr>
+            <a:r>
+              <a:rPr lang="en-US" sz="2700" i="1" dirty="0">
+                <a:solidFill>
+                  <a:srgbClr val="1E2761"/>
                 </a:solidFill>
                 <a:latin typeface="Cambria" pitchFamily="34" charset="0"/>
                 <a:ea typeface="Cambria" pitchFamily="34" charset="-122"/>
                 <a:cs typeface="Cambria" pitchFamily="34" charset="-120"/>
               </a:rPr>
-              <a:t>Wir untersuchen die Appell-Ebene.</a:t>
+              <a:t>„Mein Schreiben handelte von Dir, ich klagte dort ja nur, was ich an Deiner Brust nicht klagen konnte.“</a:t>
+            </a:r>
+            <a:endParaRPr lang="en-US" sz="2700" dirty="0"/>
+          </a:p>
+        </p:txBody>
+      </p:sp>
+      <p:sp>
+        <p:nvSpPr>
+          <p:cNvPr id="10" name="Text 8"/>
+          <p:cNvSpPr txBox="1"/>
+          <p:nvPr/>
+        </p:nvSpPr>
+        <p:spPr>
+          <a:xfrm>
+            <a:off x="457200" y="5212080"/>
+            <a:ext cx="11247120" cy="457200"/>
+          </a:xfrm>
+          <a:prstGeom prst="rect">
+            <a:avLst/>
+          </a:prstGeom>
+          <a:noFill/>
+          <a:ln/>
+        </p:spPr>
+        <p:txBody>
+          <a:bodyPr wrap="square" lIns="0" tIns="0" rIns="0" bIns="0" rtlCol="0" anchor="t"/>
+          <a:lstStyle/>
+          <a:p>
+            <a:pPr algn="r" indent="0" marL="0">
+              <a:buNone/>
+            </a:pPr>
+            <a:r>
+              <a:rPr lang="en-US" sz="2700" dirty="0">
+                <a:solidFill>
+                  <a:srgbClr val="5B6B8C"/>
+                </a:solidFill>
+                <a:latin typeface="Calibri" pitchFamily="34" charset="0"/>
+                <a:ea typeface="Calibri" pitchFamily="34" charset="-122"/>
+                <a:cs typeface="Calibri" pitchFamily="34" charset="-120"/>
+              </a:rPr>
+              <a:t>Franz Kafka: „Brief an den Vater“ (1919), S. 14</a:t>
             </a:r>
             <a:endParaRPr lang="en-US" sz="2700" dirty="0"/>
           </a:p>
@@ -6239,7 +7360,7 @@
                 <a:ea typeface="Cambria" pitchFamily="34" charset="-122"/>
                 <a:cs typeface="Cambria" pitchFamily="34" charset="-120"/>
               </a:rPr>
-              <a:t>Information: Der Appell</a:t>
+              <a:t>Kafka und sein Vater</a:t>
             </a:r>
             <a:endParaRPr lang="en-US" sz="3000" dirty="0"/>
           </a:p>
@@ -6278,26 +7399,108 @@
                 <a:ea typeface="Calibri" pitchFamily="34" charset="-122"/>
                 <a:cs typeface="Calibri" pitchFamily="34" charset="-120"/>
               </a:rPr>
-              <a:t>INFORMIEREN</a:t>
-            </a:r>
-            <a:endParaRPr lang="en-US" sz="2700" dirty="0"/>
-          </a:p>
-        </p:txBody>
-      </p:sp>
-      <p:sp>
-        <p:nvSpPr>
-          <p:cNvPr id="5" name="Shape 3"/>
+              <a:t>VORWISSEN</a:t>
+            </a:r>
+            <a:endParaRPr lang="en-US" sz="2700" dirty="0"/>
+          </a:p>
+        </p:txBody>
+      </p:sp>
+      <p:sp>
+        <p:nvSpPr>
+          <p:cNvPr id="5" name="Text 3"/>
+          <p:cNvSpPr txBox="1"/>
+          <p:nvPr/>
+        </p:nvSpPr>
+        <p:spPr>
+          <a:xfrm>
+            <a:off x="731520" y="1280160"/>
+            <a:ext cx="10789920" cy="3291840"/>
+          </a:xfrm>
+          <a:prstGeom prst="rect">
+            <a:avLst/>
+          </a:prstGeom>
+          <a:noFill/>
+          <a:ln/>
+        </p:spPr>
+        <p:txBody>
+          <a:bodyPr wrap="square" lIns="0" tIns="0" rIns="0" bIns="0" rtlCol="0" anchor="t"/>
+          <a:lstStyle/>
+          <a:p>
+            <a:pPr marL="304800" indent="-304800">
+              <a:spcAft>
+                <a:spcPts val="1600"/>
+              </a:spcAft>
+              <a:buSzPct val="100000"/>
+              <a:buChar char="•"/>
+            </a:pPr>
+            <a:r>
+              <a:rPr lang="en-US" sz="2700" dirty="0">
+                <a:solidFill>
+                  <a:srgbClr val="1E2761"/>
+                </a:solidFill>
+                <a:latin typeface="Calibri" pitchFamily="34" charset="0"/>
+                <a:ea typeface="Calibri" pitchFamily="34" charset="-122"/>
+                <a:cs typeface="Calibri" pitchFamily="34" charset="-120"/>
+              </a:rPr>
+              <a:t>Die Beziehung ist gestört – der Sohn hat Furcht, der Vater versteht ihn nicht.</a:t>
+            </a:r>
+            <a:endParaRPr lang="en-US" sz="2700" dirty="0"/>
+          </a:p>
+          <a:p>
+            <a:pPr marL="304800" indent="-304800">
+              <a:spcAft>
+                <a:spcPts val="1600"/>
+              </a:spcAft>
+              <a:buSzPct val="100000"/>
+              <a:buChar char="•"/>
+            </a:pPr>
+            <a:r>
+              <a:rPr lang="en-US" sz="2700" dirty="0">
+                <a:solidFill>
+                  <a:srgbClr val="1E2761"/>
+                </a:solidFill>
+                <a:latin typeface="Calibri" pitchFamily="34" charset="0"/>
+                <a:ea typeface="Calibri" pitchFamily="34" charset="-122"/>
+                <a:cs typeface="Calibri" pitchFamily="34" charset="-120"/>
+              </a:rPr>
+              <a:t>Max Brod hat deshalb an den Vater geschrieben.</a:t>
+            </a:r>
+            <a:endParaRPr lang="en-US" sz="2700" dirty="0"/>
+          </a:p>
+          <a:p>
+            <a:pPr marL="304800" indent="-304800">
+              <a:buSzPct val="100000"/>
+              <a:buChar char="•"/>
+            </a:pPr>
+            <a:r>
+              <a:rPr lang="en-US" sz="2700" b="1" dirty="0">
+                <a:solidFill>
+                  <a:srgbClr val="1E2761"/>
+                </a:solidFill>
+                <a:latin typeface="Calibri" pitchFamily="34" charset="0"/>
+                <a:ea typeface="Calibri" pitchFamily="34" charset="-122"/>
+                <a:cs typeface="Calibri" pitchFamily="34" charset="-120"/>
+              </a:rPr>
+              <a:t>Heute: Was will Kafka selbst von seinem Vater?</a:t>
+            </a:r>
+            <a:endParaRPr lang="en-US" sz="2700" dirty="0"/>
+          </a:p>
+        </p:txBody>
+      </p:sp>
+      <p:sp>
+        <p:nvSpPr>
+          <p:cNvPr id="6" name="Shape 4"/>
           <p:cNvSpPr/>
           <p:nvPr/>
         </p:nvSpPr>
         <p:spPr>
           <a:xfrm>
-            <a:off x="457200" y="1188720"/>
-            <a:ext cx="11247120" cy="1508760"/>
+            <a:off x="457200" y="4846320"/>
+            <a:ext cx="11247120" cy="1097280"/>
           </a:xfrm>
           <a:prstGeom prst="roundRect">
             <a:avLst>
-              <a:gd name="adj" fmla="val 4848"/>
+              <a:gd name="adj" fmla="val 6667"/>
             </a:avLst>
           </a:prstGeom>
           <a:solidFill>
@@ -6308,14 +7511,14 @@
       </p:sp>
       <p:sp>
         <p:nvSpPr>
-          <p:cNvPr id="6" name="Text 4"/>
-          <p:cNvSpPr txBox="1"/>
-          <p:nvPr/>
-        </p:nvSpPr>
-        <p:spPr>
-          <a:xfrm>
-            <a:off x="731520" y="1188720"/>
-            <a:ext cx="10789920" cy="1508760"/>
+          <p:cNvPr id="7" name="Text 5"/>
+          <p:cNvSpPr txBox="1"/>
+          <p:nvPr/>
+        </p:nvSpPr>
+        <p:spPr>
+          <a:xfrm>
+            <a:off x="731520" y="4846320"/>
+            <a:ext cx="10789920" cy="1097280"/>
           </a:xfrm>
           <a:prstGeom prst="rect">
             <a:avLst/>
@@ -6335,175 +7538,11 @@
                 <a:solidFill>
                   <a:srgbClr val="D9534F"/>
                 </a:solidFill>
-                <a:latin typeface="Calibri" pitchFamily="34" charset="0"/>
-                <a:ea typeface="Calibri" pitchFamily="34" charset="-122"/>
-                <a:cs typeface="Calibri" pitchFamily="34" charset="-120"/>
-              </a:rPr>
-              <a:t>Appell: </a:t>
-            </a:r>
-            <a:pPr indent="0" marL="0">
-              <a:buNone/>
-            </a:pPr>
-            <a:r>
-              <a:rPr lang="en-US" sz="2700" dirty="0">
-                <a:solidFill>
-                  <a:srgbClr val="1E2761"/>
-                </a:solidFill>
-                <a:latin typeface="Calibri" pitchFamily="34" charset="0"/>
-                <a:ea typeface="Calibri" pitchFamily="34" charset="-122"/>
-                <a:cs typeface="Calibri" pitchFamily="34" charset="-120"/>
-              </a:rPr>
-              <a:t>Mit dieser Seite einer Nachricht will der Sender erreichen, dass der Empfänger etwas tut, denkt oder fühlt.</a:t>
-            </a:r>
-            <a:endParaRPr lang="en-US" sz="2700" dirty="0"/>
-          </a:p>
-        </p:txBody>
-      </p:sp>
-      <p:sp>
-        <p:nvSpPr>
-          <p:cNvPr id="7" name="Shape 5"/>
-          <p:cNvSpPr/>
-          <p:nvPr/>
-        </p:nvSpPr>
-        <p:spPr>
-          <a:xfrm>
-            <a:off x="457200" y="2880360"/>
-            <a:ext cx="11247120" cy="1508760"/>
-          </a:xfrm>
-          <a:prstGeom prst="roundRect">
-            <a:avLst>
-              <a:gd name="adj" fmla="val 4848"/>
-            </a:avLst>
-          </a:prstGeom>
-          <a:solidFill>
-            <a:srgbClr val="F4F7FD"/>
-          </a:solidFill>
-          <a:ln/>
-        </p:spPr>
-      </p:sp>
-      <p:sp>
-        <p:nvSpPr>
-          <p:cNvPr id="8" name="Text 6"/>
-          <p:cNvSpPr txBox="1"/>
-          <p:nvPr/>
-        </p:nvSpPr>
-        <p:spPr>
-          <a:xfrm>
-            <a:off x="731520" y="2880360"/>
-            <a:ext cx="10789920" cy="1508760"/>
-          </a:xfrm>
-          <a:prstGeom prst="rect">
-            <a:avLst/>
-          </a:prstGeom>
-          <a:noFill/>
-          <a:ln/>
-        </p:spPr>
-        <p:txBody>
-          <a:bodyPr wrap="square" lIns="0" tIns="0" rIns="0" bIns="0" rtlCol="0" anchor="ctr"/>
-          <a:lstStyle/>
-          <a:p>
-            <a:pPr indent="0" marL="0">
-              <a:buNone/>
-            </a:pPr>
-            <a:r>
-              <a:rPr lang="en-US" sz="2700" b="1" dirty="0">
-                <a:solidFill>
-                  <a:srgbClr val="1E2761"/>
-                </a:solidFill>
-                <a:latin typeface="Calibri" pitchFamily="34" charset="0"/>
-                <a:ea typeface="Calibri" pitchFamily="34" charset="-122"/>
-                <a:cs typeface="Calibri" pitchFamily="34" charset="-120"/>
-              </a:rPr>
-              <a:t>offen: </a:t>
-            </a:r>
-            <a:pPr indent="0" marL="0">
-              <a:buNone/>
-            </a:pPr>
-            <a:r>
-              <a:rPr lang="en-US" sz="2700" dirty="0">
-                <a:solidFill>
-                  <a:srgbClr val="1E2761"/>
-                </a:solidFill>
-                <a:latin typeface="Calibri" pitchFamily="34" charset="0"/>
-                <a:ea typeface="Calibri" pitchFamily="34" charset="-122"/>
-                <a:cs typeface="Calibri" pitchFamily="34" charset="-120"/>
-              </a:rPr>
-              <a:t>direkt ausgesprochen, z. B. als Bitte: „Hör mir bitte zu!“</a:t>
-            </a:r>
-            <a:endParaRPr lang="en-US" sz="2700" dirty="0"/>
-          </a:p>
-        </p:txBody>
-      </p:sp>
-      <p:sp>
-        <p:nvSpPr>
-          <p:cNvPr id="9" name="Shape 7"/>
-          <p:cNvSpPr/>
-          <p:nvPr/>
-        </p:nvSpPr>
-        <p:spPr>
-          <a:xfrm>
-            <a:off x="457200" y="4572000"/>
-            <a:ext cx="11247120" cy="1508760"/>
-          </a:xfrm>
-          <a:prstGeom prst="roundRect">
-            <a:avLst>
-              <a:gd name="adj" fmla="val 4848"/>
-            </a:avLst>
-          </a:prstGeom>
-          <a:solidFill>
-            <a:srgbClr val="F4F7FD"/>
-          </a:solidFill>
-          <a:ln/>
-        </p:spPr>
-      </p:sp>
-      <p:sp>
-        <p:nvSpPr>
-          <p:cNvPr id="10" name="Text 8"/>
-          <p:cNvSpPr txBox="1"/>
-          <p:nvPr/>
-        </p:nvSpPr>
-        <p:spPr>
-          <a:xfrm>
-            <a:off x="731520" y="4572000"/>
-            <a:ext cx="10789920" cy="1508760"/>
-          </a:xfrm>
-          <a:prstGeom prst="rect">
-            <a:avLst/>
-          </a:prstGeom>
-          <a:noFill/>
-          <a:ln/>
-        </p:spPr>
-        <p:txBody>
-          <a:bodyPr wrap="square" lIns="0" tIns="0" rIns="0" bIns="0" rtlCol="0" anchor="ctr"/>
-          <a:lstStyle/>
-          <a:p>
-            <a:pPr indent="0" marL="0">
-              <a:buNone/>
-            </a:pPr>
-            <a:r>
-              <a:rPr lang="en-US" sz="2700" b="1" dirty="0">
-                <a:solidFill>
-                  <a:srgbClr val="1E2761"/>
-                </a:solidFill>
-                <a:latin typeface="Calibri" pitchFamily="34" charset="0"/>
-                <a:ea typeface="Calibri" pitchFamily="34" charset="-122"/>
-                <a:cs typeface="Calibri" pitchFamily="34" charset="-120"/>
-              </a:rPr>
-              <a:t>verdeckt: </a:t>
-            </a:r>
-            <a:pPr indent="0" marL="0">
-              <a:buNone/>
-            </a:pPr>
-            <a:r>
-              <a:rPr lang="en-US" sz="2700" dirty="0">
-                <a:solidFill>
-                  <a:srgbClr val="1E2761"/>
-                </a:solidFill>
-                <a:latin typeface="Calibri" pitchFamily="34" charset="0"/>
-                <a:ea typeface="Calibri" pitchFamily="34" charset="-122"/>
-                <a:cs typeface="Calibri" pitchFamily="34" charset="-120"/>
-              </a:rPr>
-              <a:t>versteckt in einem Wunsch, einer Frage oder einer Beschreibung: „Du hörst mir nie zu.“</a:t>
+                <a:latin typeface="Cambria" pitchFamily="34" charset="0"/>
+                <a:ea typeface="Cambria" pitchFamily="34" charset="-122"/>
+                <a:cs typeface="Cambria" pitchFamily="34" charset="-120"/>
+              </a:rPr>
+              <a:t>Wir untersuchen die Appell-Ebene.</a:t>
             </a:r>
             <a:endParaRPr lang="en-US" sz="2700" dirty="0"/>
           </a:p>

</xml_diff>